<commit_message>
docs: cập nhật bộ Slide PowerPoint sang tông màu sáng (Enterprise Light Theme)
</commit_message>
<xml_diff>
--- a/docs/TENDOO_AI_PHASE_3_EXECUTIVE_REPORT.pptx
+++ b/docs/TENDOO_AI_PHASE_3_EXECUTIVE_REPORT.pptx
@@ -3112,7 +3112,7 @@
             <a:avLst/>
           </a:prstGeom>
           <a:solidFill>
-            <a:srgbClr val="0A0D14"/>
+            <a:srgbClr val="F8FAFC"/>
           </a:solidFill>
           <a:ln>
             <a:noFill/>
@@ -3165,7 +3165,7 @@
             <a:pPr>
               <a:defRPr sz="1300" b="1">
                 <a:solidFill>
-                  <a:srgbClr val="00F2FE"/>
+                  <a:srgbClr val="0284C7"/>
                 </a:solidFill>
                 <a:latin typeface="Segoe UI"/>
               </a:defRPr>
@@ -3181,7 +3181,7 @@
               </a:spcBef>
               <a:defRPr sz="3200" b="1">
                 <a:solidFill>
-                  <a:srgbClr val="FFFFFF"/>
+                  <a:srgbClr val="0F172A"/>
                 </a:solidFill>
                 <a:latin typeface="Segoe UI"/>
               </a:defRPr>
@@ -3197,7 +3197,7 @@
               </a:spcBef>
               <a:defRPr sz="1400">
                 <a:solidFill>
-                  <a:srgbClr val="94A3B8"/>
+                  <a:srgbClr val="64748B"/>
                 </a:solidFill>
                 <a:latin typeface="Segoe UI"/>
               </a:defRPr>
@@ -3223,11 +3223,11 @@
             <a:avLst/>
           </a:prstGeom>
           <a:solidFill>
-            <a:srgbClr val="131A2A"/>
+            <a:srgbClr val="FFFFFF"/>
           </a:solidFill>
           <a:ln w="15240">
             <a:solidFill>
-              <a:srgbClr val="26304A"/>
+              <a:srgbClr val="E2E8F0"/>
             </a:solidFill>
           </a:ln>
         </p:spPr>
@@ -3278,7 +3278,7 @@
             <a:pPr>
               <a:defRPr sz="3600" b="1">
                 <a:solidFill>
-                  <a:srgbClr val="FFFFFF"/>
+                  <a:srgbClr val="0F172A"/>
                 </a:solidFill>
                 <a:latin typeface="Segoe UI"/>
               </a:defRPr>
@@ -3294,7 +3294,7 @@
               </a:spcBef>
               <a:defRPr sz="1200" b="1">
                 <a:solidFill>
-                  <a:srgbClr val="94A3B8"/>
+                  <a:srgbClr val="64748B"/>
                 </a:solidFill>
                 <a:latin typeface="Segoe UI"/>
               </a:defRPr>
@@ -3320,11 +3320,11 @@
             <a:avLst/>
           </a:prstGeom>
           <a:solidFill>
-            <a:srgbClr val="131A2A"/>
+            <a:srgbClr val="FFFFFF"/>
           </a:solidFill>
           <a:ln w="15240">
             <a:solidFill>
-              <a:srgbClr val="26304A"/>
+              <a:srgbClr val="E2E8F0"/>
             </a:solidFill>
           </a:ln>
         </p:spPr>
@@ -3375,7 +3375,7 @@
             <a:pPr>
               <a:defRPr sz="3600" b="1">
                 <a:solidFill>
-                  <a:srgbClr val="10B981"/>
+                  <a:srgbClr val="059669"/>
                 </a:solidFill>
                 <a:latin typeface="Segoe UI"/>
               </a:defRPr>
@@ -3391,7 +3391,7 @@
               </a:spcBef>
               <a:defRPr sz="1200" b="1">
                 <a:solidFill>
-                  <a:srgbClr val="94A3B8"/>
+                  <a:srgbClr val="64748B"/>
                 </a:solidFill>
                 <a:latin typeface="Segoe UI"/>
               </a:defRPr>
@@ -3417,11 +3417,11 @@
             <a:avLst/>
           </a:prstGeom>
           <a:solidFill>
-            <a:srgbClr val="131A2A"/>
+            <a:srgbClr val="FFFFFF"/>
           </a:solidFill>
           <a:ln w="15240">
             <a:solidFill>
-              <a:srgbClr val="26304A"/>
+              <a:srgbClr val="E2E8F0"/>
             </a:solidFill>
           </a:ln>
         </p:spPr>
@@ -3472,7 +3472,7 @@
             <a:pPr>
               <a:defRPr sz="3600" b="1">
                 <a:solidFill>
-                  <a:srgbClr val="00F2FE"/>
+                  <a:srgbClr val="0284C7"/>
                 </a:solidFill>
                 <a:latin typeface="Segoe UI"/>
               </a:defRPr>
@@ -3488,7 +3488,7 @@
               </a:spcBef>
               <a:defRPr sz="1200" b="1">
                 <a:solidFill>
-                  <a:srgbClr val="94A3B8"/>
+                  <a:srgbClr val="64748B"/>
                 </a:solidFill>
                 <a:latin typeface="Segoe UI"/>
               </a:defRPr>
@@ -3514,11 +3514,11 @@
             <a:avLst/>
           </a:prstGeom>
           <a:solidFill>
-            <a:srgbClr val="131A2A"/>
+            <a:srgbClr val="FFFFFF"/>
           </a:solidFill>
           <a:ln w="15240">
             <a:solidFill>
-              <a:srgbClr val="26304A"/>
+              <a:srgbClr val="E2E8F0"/>
             </a:solidFill>
           </a:ln>
         </p:spPr>
@@ -3569,7 +3569,7 @@
             <a:pPr>
               <a:defRPr sz="3600" b="1">
                 <a:solidFill>
-                  <a:srgbClr val="F59E0B"/>
+                  <a:srgbClr val="D97706"/>
                 </a:solidFill>
                 <a:latin typeface="Segoe UI"/>
               </a:defRPr>
@@ -3585,7 +3585,7 @@
               </a:spcBef>
               <a:defRPr sz="1200" b="1">
                 <a:solidFill>
-                  <a:srgbClr val="94A3B8"/>
+                  <a:srgbClr val="64748B"/>
                 </a:solidFill>
                 <a:latin typeface="Segoe UI"/>
               </a:defRPr>
@@ -3629,7 +3629,7 @@
             <a:avLst/>
           </a:prstGeom>
           <a:solidFill>
-            <a:srgbClr val="0A0D14"/>
+            <a:srgbClr val="F8FAFC"/>
           </a:solidFill>
           <a:ln>
             <a:noFill/>
@@ -3682,7 +3682,7 @@
             <a:pPr>
               <a:defRPr sz="1100" b="1">
                 <a:solidFill>
-                  <a:srgbClr val="00F2FE"/>
+                  <a:srgbClr val="0284C7"/>
                 </a:solidFill>
                 <a:latin typeface="Segoe UI"/>
               </a:defRPr>
@@ -3718,7 +3718,7 @@
             <a:pPr algn="r">
               <a:defRPr sz="1100" b="1">
                 <a:solidFill>
-                  <a:srgbClr val="94A3B8"/>
+                  <a:srgbClr val="64748B"/>
                 </a:solidFill>
                 <a:latin typeface="Segoe UI"/>
               </a:defRPr>
@@ -3754,7 +3754,7 @@
             <a:pPr>
               <a:defRPr sz="2400" b="1">
                 <a:solidFill>
-                  <a:srgbClr val="FFFFFF"/>
+                  <a:srgbClr val="0F172A"/>
                 </a:solidFill>
                 <a:latin typeface="Segoe UI"/>
               </a:defRPr>
@@ -3780,11 +3780,11 @@
             <a:avLst/>
           </a:prstGeom>
           <a:solidFill>
-            <a:srgbClr val="131A2A"/>
+            <a:srgbClr val="FFFFFF"/>
           </a:solidFill>
           <a:ln w="15240">
             <a:solidFill>
-              <a:srgbClr val="26304A"/>
+              <a:srgbClr val="E2E8F0"/>
             </a:solidFill>
           </a:ln>
         </p:spPr>
@@ -3835,7 +3835,7 @@
             <a:pPr>
               <a:defRPr sz="1500" b="1">
                 <a:solidFill>
-                  <a:srgbClr val="F59E0B"/>
+                  <a:srgbClr val="D97706"/>
                 </a:solidFill>
               </a:defRPr>
             </a:pPr>
@@ -3850,7 +3850,7 @@
               </a:spcBef>
               <a:defRPr sz="1100">
                 <a:solidFill>
-                  <a:srgbClr val="FFFFFF"/>
+                  <a:srgbClr val="0F172A"/>
                 </a:solidFill>
               </a:defRPr>
             </a:pPr>
@@ -3900,11 +3900,11 @@
             <a:avLst/>
           </a:prstGeom>
           <a:solidFill>
-            <a:srgbClr val="1A243C"/>
+            <a:srgbClr val="F0F9FF"/>
           </a:solidFill>
           <a:ln w="15240">
             <a:solidFill>
-              <a:srgbClr val="10B981"/>
+              <a:srgbClr val="BAE6FD"/>
             </a:solidFill>
           </a:ln>
         </p:spPr>
@@ -3955,7 +3955,7 @@
             <a:pPr>
               <a:defRPr sz="1500" b="1">
                 <a:solidFill>
-                  <a:srgbClr val="10B981"/>
+                  <a:srgbClr val="059669"/>
                 </a:solidFill>
               </a:defRPr>
             </a:pPr>
@@ -3970,7 +3970,7 @@
               </a:spcBef>
               <a:defRPr sz="1100">
                 <a:solidFill>
-                  <a:srgbClr val="FFFFFF"/>
+                  <a:srgbClr val="0F172A"/>
                 </a:solidFill>
               </a:defRPr>
             </a:pPr>
@@ -4028,7 +4028,7 @@
             <a:avLst/>
           </a:prstGeom>
           <a:solidFill>
-            <a:srgbClr val="0A0D14"/>
+            <a:srgbClr val="F8FAFC"/>
           </a:solidFill>
           <a:ln>
             <a:noFill/>
@@ -4081,7 +4081,7 @@
             <a:pPr>
               <a:defRPr sz="1100" b="1">
                 <a:solidFill>
-                  <a:srgbClr val="00F2FE"/>
+                  <a:srgbClr val="0284C7"/>
                 </a:solidFill>
                 <a:latin typeface="Segoe UI"/>
               </a:defRPr>
@@ -4117,7 +4117,7 @@
             <a:pPr algn="r">
               <a:defRPr sz="1100" b="1">
                 <a:solidFill>
-                  <a:srgbClr val="94A3B8"/>
+                  <a:srgbClr val="64748B"/>
                 </a:solidFill>
                 <a:latin typeface="Segoe UI"/>
               </a:defRPr>
@@ -4153,7 +4153,7 @@
             <a:pPr>
               <a:defRPr sz="2400" b="1">
                 <a:solidFill>
-                  <a:srgbClr val="FFFFFF"/>
+                  <a:srgbClr val="0F172A"/>
                 </a:solidFill>
                 <a:latin typeface="Segoe UI"/>
               </a:defRPr>
@@ -4179,11 +4179,11 @@
             <a:avLst/>
           </a:prstGeom>
           <a:solidFill>
-            <a:srgbClr val="131A2A"/>
+            <a:srgbClr val="FFFFFF"/>
           </a:solidFill>
           <a:ln w="15240">
             <a:solidFill>
-              <a:srgbClr val="26304A"/>
+              <a:srgbClr val="E2E8F0"/>
             </a:solidFill>
           </a:ln>
         </p:spPr>
@@ -4234,7 +4234,7 @@
             <a:pPr>
               <a:defRPr sz="1400" b="1">
                 <a:solidFill>
-                  <a:srgbClr val="9061F9"/>
+                  <a:srgbClr val="7C3AED"/>
                 </a:solidFill>
                 <a:latin typeface="Segoe UI"/>
               </a:defRPr>
@@ -4250,7 +4250,7 @@
               </a:spcBef>
               <a:defRPr sz="1200">
                 <a:solidFill>
-                  <a:srgbClr val="FFFFFF"/>
+                  <a:srgbClr val="0F172A"/>
                 </a:solidFill>
                 <a:latin typeface="Segoe UI"/>
               </a:defRPr>
@@ -4284,11 +4284,11 @@
             <a:avLst/>
           </a:prstGeom>
           <a:solidFill>
-            <a:srgbClr val="131A2A"/>
+            <a:srgbClr val="FFFFFF"/>
           </a:solidFill>
           <a:ln w="15240">
             <a:solidFill>
-              <a:srgbClr val="26304A"/>
+              <a:srgbClr val="E2E8F0"/>
             </a:solidFill>
           </a:ln>
         </p:spPr>
@@ -4339,7 +4339,7 @@
             <a:pPr>
               <a:defRPr sz="1400" b="1">
                 <a:solidFill>
-                  <a:srgbClr val="00F2FE"/>
+                  <a:srgbClr val="0284C7"/>
                 </a:solidFill>
                 <a:latin typeface="Segoe UI"/>
               </a:defRPr>
@@ -4355,7 +4355,7 @@
               </a:spcBef>
               <a:defRPr sz="1200">
                 <a:solidFill>
-                  <a:srgbClr val="FFFFFF"/>
+                  <a:srgbClr val="0F172A"/>
                 </a:solidFill>
                 <a:latin typeface="Segoe UI"/>
               </a:defRPr>
@@ -4389,11 +4389,11 @@
             <a:avLst/>
           </a:prstGeom>
           <a:solidFill>
-            <a:srgbClr val="131A2A"/>
+            <a:srgbClr val="FFFFFF"/>
           </a:solidFill>
           <a:ln w="15240">
             <a:solidFill>
-              <a:srgbClr val="26304A"/>
+              <a:srgbClr val="E2E8F0"/>
             </a:solidFill>
           </a:ln>
         </p:spPr>
@@ -4444,7 +4444,7 @@
             <a:pPr>
               <a:defRPr sz="1400" b="1">
                 <a:solidFill>
-                  <a:srgbClr val="10B981"/>
+                  <a:srgbClr val="059669"/>
                 </a:solidFill>
                 <a:latin typeface="Segoe UI"/>
               </a:defRPr>
@@ -4460,7 +4460,7 @@
               </a:spcBef>
               <a:defRPr sz="1200">
                 <a:solidFill>
-                  <a:srgbClr val="FFFFFF"/>
+                  <a:srgbClr val="0F172A"/>
                 </a:solidFill>
                 <a:latin typeface="Segoe UI"/>
               </a:defRPr>
@@ -4512,7 +4512,7 @@
             <a:avLst/>
           </a:prstGeom>
           <a:solidFill>
-            <a:srgbClr val="0A0D14"/>
+            <a:srgbClr val="F8FAFC"/>
           </a:solidFill>
           <a:ln>
             <a:noFill/>
@@ -4565,7 +4565,7 @@
             <a:pPr>
               <a:defRPr sz="1100" b="1">
                 <a:solidFill>
-                  <a:srgbClr val="00F2FE"/>
+                  <a:srgbClr val="0284C7"/>
                 </a:solidFill>
                 <a:latin typeface="Segoe UI"/>
               </a:defRPr>
@@ -4601,7 +4601,7 @@
             <a:pPr algn="r">
               <a:defRPr sz="1100" b="1">
                 <a:solidFill>
-                  <a:srgbClr val="94A3B8"/>
+                  <a:srgbClr val="64748B"/>
                 </a:solidFill>
                 <a:latin typeface="Segoe UI"/>
               </a:defRPr>
@@ -4637,7 +4637,7 @@
             <a:pPr>
               <a:defRPr sz="2400" b="1">
                 <a:solidFill>
-                  <a:srgbClr val="FFFFFF"/>
+                  <a:srgbClr val="0F172A"/>
                 </a:solidFill>
                 <a:latin typeface="Segoe UI"/>
               </a:defRPr>
@@ -4663,11 +4663,11 @@
             <a:avLst/>
           </a:prstGeom>
           <a:solidFill>
-            <a:srgbClr val="131A2A"/>
+            <a:srgbClr val="FFFFFF"/>
           </a:solidFill>
           <a:ln w="15240">
             <a:solidFill>
-              <a:srgbClr val="26304A"/>
+              <a:srgbClr val="E2E8F0"/>
             </a:solidFill>
           </a:ln>
         </p:spPr>
@@ -4718,7 +4718,7 @@
             <a:pPr>
               <a:defRPr sz="1600" b="1">
                 <a:solidFill>
-                  <a:srgbClr val="F59E0B"/>
+                  <a:srgbClr val="D97706"/>
                 </a:solidFill>
                 <a:latin typeface="Segoe UI"/>
               </a:defRPr>
@@ -4734,7 +4734,7 @@
               </a:spcBef>
               <a:defRPr sz="1200">
                 <a:solidFill>
-                  <a:srgbClr val="FFFFFF"/>
+                  <a:srgbClr val="0F172A"/>
                 </a:solidFill>
                 <a:latin typeface="Segoe UI"/>
               </a:defRPr>
@@ -4765,11 +4765,11 @@
             <a:avLst/>
           </a:prstGeom>
           <a:solidFill>
-            <a:srgbClr val="1A243C"/>
+            <a:srgbClr val="F0F9FF"/>
           </a:solidFill>
           <a:ln w="15240">
             <a:solidFill>
-              <a:srgbClr val="26304A"/>
+              <a:srgbClr val="BAE6FD"/>
             </a:solidFill>
           </a:ln>
         </p:spPr>
@@ -4820,7 +4820,7 @@
             <a:pPr>
               <a:defRPr sz="1600" b="1">
                 <a:solidFill>
-                  <a:srgbClr val="00F2FE"/>
+                  <a:srgbClr val="0284C7"/>
                 </a:solidFill>
                 <a:latin typeface="Segoe UI"/>
               </a:defRPr>
@@ -4836,7 +4836,7 @@
               </a:spcBef>
               <a:defRPr sz="1200">
                 <a:solidFill>
-                  <a:srgbClr val="FFFFFF"/>
+                  <a:srgbClr val="0F172A"/>
                 </a:solidFill>
                 <a:latin typeface="Segoe UI"/>
               </a:defRPr>
@@ -4890,7 +4890,7 @@
             <a:avLst/>
           </a:prstGeom>
           <a:solidFill>
-            <a:srgbClr val="0A0D14"/>
+            <a:srgbClr val="F8FAFC"/>
           </a:solidFill>
           <a:ln>
             <a:noFill/>
@@ -4943,7 +4943,7 @@
             <a:pPr>
               <a:defRPr sz="1100" b="1">
                 <a:solidFill>
-                  <a:srgbClr val="00F2FE"/>
+                  <a:srgbClr val="0284C7"/>
                 </a:solidFill>
                 <a:latin typeface="Segoe UI"/>
               </a:defRPr>
@@ -4979,7 +4979,7 @@
             <a:pPr algn="r">
               <a:defRPr sz="1100" b="1">
                 <a:solidFill>
-                  <a:srgbClr val="94A3B8"/>
+                  <a:srgbClr val="64748B"/>
                 </a:solidFill>
                 <a:latin typeface="Segoe UI"/>
               </a:defRPr>
@@ -5015,7 +5015,7 @@
             <a:pPr>
               <a:defRPr sz="2400" b="1">
                 <a:solidFill>
-                  <a:srgbClr val="FFFFFF"/>
+                  <a:srgbClr val="0F172A"/>
                 </a:solidFill>
                 <a:latin typeface="Segoe UI"/>
               </a:defRPr>
@@ -5041,11 +5041,11 @@
             <a:avLst/>
           </a:prstGeom>
           <a:solidFill>
-            <a:srgbClr val="131A2A"/>
+            <a:srgbClr val="FFFFFF"/>
           </a:solidFill>
           <a:ln w="15240">
             <a:solidFill>
-              <a:srgbClr val="26304A"/>
+              <a:srgbClr val="E2E8F0"/>
             </a:solidFill>
           </a:ln>
         </p:spPr>
@@ -5096,7 +5096,7 @@
             <a:pPr>
               <a:defRPr sz="1400" b="1">
                 <a:solidFill>
-                  <a:srgbClr val="00F2FE"/>
+                  <a:srgbClr val="0284C7"/>
                 </a:solidFill>
                 <a:latin typeface="Segoe UI"/>
               </a:defRPr>
@@ -5112,7 +5112,7 @@
               </a:spcBef>
               <a:defRPr sz="1200">
                 <a:solidFill>
-                  <a:srgbClr val="FFFFFF"/>
+                  <a:srgbClr val="0F172A"/>
                 </a:solidFill>
                 <a:latin typeface="Segoe UI"/>
               </a:defRPr>
@@ -5138,11 +5138,11 @@
             <a:avLst/>
           </a:prstGeom>
           <a:solidFill>
-            <a:srgbClr val="131A2A"/>
+            <a:srgbClr val="FFFFFF"/>
           </a:solidFill>
           <a:ln w="15240">
             <a:solidFill>
-              <a:srgbClr val="26304A"/>
+              <a:srgbClr val="E2E8F0"/>
             </a:solidFill>
           </a:ln>
         </p:spPr>
@@ -5193,7 +5193,7 @@
             <a:pPr>
               <a:defRPr sz="1400" b="1">
                 <a:solidFill>
-                  <a:srgbClr val="10B981"/>
+                  <a:srgbClr val="059669"/>
                 </a:solidFill>
                 <a:latin typeface="Segoe UI"/>
               </a:defRPr>
@@ -5209,7 +5209,7 @@
               </a:spcBef>
               <a:defRPr sz="1200">
                 <a:solidFill>
-                  <a:srgbClr val="FFFFFF"/>
+                  <a:srgbClr val="0F172A"/>
                 </a:solidFill>
                 <a:latin typeface="Segoe UI"/>
               </a:defRPr>
@@ -5235,11 +5235,11 @@
             <a:avLst/>
           </a:prstGeom>
           <a:solidFill>
-            <a:srgbClr val="131A2A"/>
+            <a:srgbClr val="FFFFFF"/>
           </a:solidFill>
           <a:ln w="15240">
             <a:solidFill>
-              <a:srgbClr val="26304A"/>
+              <a:srgbClr val="E2E8F0"/>
             </a:solidFill>
           </a:ln>
         </p:spPr>
@@ -5290,7 +5290,7 @@
             <a:pPr>
               <a:defRPr sz="1400" b="1">
                 <a:solidFill>
-                  <a:srgbClr val="9061F9"/>
+                  <a:srgbClr val="7C3AED"/>
                 </a:solidFill>
                 <a:latin typeface="Segoe UI"/>
               </a:defRPr>
@@ -5306,7 +5306,7 @@
               </a:spcBef>
               <a:defRPr sz="1200">
                 <a:solidFill>
-                  <a:srgbClr val="FFFFFF"/>
+                  <a:srgbClr val="0F172A"/>
                 </a:solidFill>
                 <a:latin typeface="Segoe UI"/>
               </a:defRPr>
@@ -5350,7 +5350,7 @@
             <a:avLst/>
           </a:prstGeom>
           <a:solidFill>
-            <a:srgbClr val="0A0D14"/>
+            <a:srgbClr val="F8FAFC"/>
           </a:solidFill>
           <a:ln>
             <a:noFill/>
@@ -5403,7 +5403,7 @@
             <a:pPr>
               <a:defRPr sz="1100" b="1">
                 <a:solidFill>
-                  <a:srgbClr val="00F2FE"/>
+                  <a:srgbClr val="0284C7"/>
                 </a:solidFill>
                 <a:latin typeface="Segoe UI"/>
               </a:defRPr>
@@ -5439,7 +5439,7 @@
             <a:pPr algn="r">
               <a:defRPr sz="1100" b="1">
                 <a:solidFill>
-                  <a:srgbClr val="94A3B8"/>
+                  <a:srgbClr val="64748B"/>
                 </a:solidFill>
                 <a:latin typeface="Segoe UI"/>
               </a:defRPr>
@@ -5475,7 +5475,7 @@
             <a:pPr>
               <a:defRPr sz="2400" b="1">
                 <a:solidFill>
-                  <a:srgbClr val="FFFFFF"/>
+                  <a:srgbClr val="0F172A"/>
                 </a:solidFill>
                 <a:latin typeface="Segoe UI"/>
               </a:defRPr>
@@ -5501,11 +5501,11 @@
             <a:avLst/>
           </a:prstGeom>
           <a:solidFill>
-            <a:srgbClr val="131A2A"/>
+            <a:srgbClr val="FFFFFF"/>
           </a:solidFill>
           <a:ln w="15240">
             <a:solidFill>
-              <a:srgbClr val="26304A"/>
+              <a:srgbClr val="E2E8F0"/>
             </a:solidFill>
           </a:ln>
         </p:spPr>
@@ -5556,7 +5556,7 @@
             <a:pPr>
               <a:defRPr sz="1500" b="1">
                 <a:solidFill>
-                  <a:srgbClr val="00F2FE"/>
+                  <a:srgbClr val="0284C7"/>
                 </a:solidFill>
               </a:defRPr>
             </a:pPr>
@@ -5571,7 +5571,7 @@
               </a:spcBef>
               <a:defRPr sz="1200">
                 <a:solidFill>
-                  <a:srgbClr val="FFFFFF"/>
+                  <a:srgbClr val="0F172A"/>
                 </a:solidFill>
               </a:defRPr>
             </a:pPr>
@@ -5606,11 +5606,11 @@
             <a:avLst/>
           </a:prstGeom>
           <a:solidFill>
-            <a:srgbClr val="1A243C"/>
+            <a:srgbClr val="F0F9FF"/>
           </a:solidFill>
           <a:ln w="15240">
             <a:solidFill>
-              <a:srgbClr val="00F2FE"/>
+              <a:srgbClr val="BAE6FD"/>
             </a:solidFill>
           </a:ln>
         </p:spPr>
@@ -5661,7 +5661,7 @@
             <a:pPr algn="ctr">
               <a:defRPr sz="1300" b="1">
                 <a:solidFill>
-                  <a:srgbClr val="00F2FE"/>
+                  <a:srgbClr val="0284C7"/>
                 </a:solidFill>
               </a:defRPr>
             </a:pPr>
@@ -5712,7 +5712,7 @@
             <a:avLst/>
           </a:prstGeom>
           <a:solidFill>
-            <a:srgbClr val="0A0D14"/>
+            <a:srgbClr val="F8FAFC"/>
           </a:solidFill>
           <a:ln>
             <a:noFill/>
@@ -5765,7 +5765,7 @@
             <a:pPr>
               <a:defRPr sz="1100" b="1">
                 <a:solidFill>
-                  <a:srgbClr val="00F2FE"/>
+                  <a:srgbClr val="0284C7"/>
                 </a:solidFill>
                 <a:latin typeface="Segoe UI"/>
               </a:defRPr>
@@ -5801,7 +5801,7 @@
             <a:pPr algn="r">
               <a:defRPr sz="1100" b="1">
                 <a:solidFill>
-                  <a:srgbClr val="94A3B8"/>
+                  <a:srgbClr val="64748B"/>
                 </a:solidFill>
                 <a:latin typeface="Segoe UI"/>
               </a:defRPr>
@@ -5837,7 +5837,7 @@
             <a:pPr>
               <a:defRPr sz="2400" b="1">
                 <a:solidFill>
-                  <a:srgbClr val="FFFFFF"/>
+                  <a:srgbClr val="0F172A"/>
                 </a:solidFill>
                 <a:latin typeface="Segoe UI"/>
               </a:defRPr>
@@ -5863,11 +5863,11 @@
             <a:avLst/>
           </a:prstGeom>
           <a:solidFill>
-            <a:srgbClr val="131A2A"/>
+            <a:srgbClr val="FFFFFF"/>
           </a:solidFill>
           <a:ln w="15240">
             <a:solidFill>
-              <a:srgbClr val="26304A"/>
+              <a:srgbClr val="E2E8F0"/>
             </a:solidFill>
           </a:ln>
         </p:spPr>
@@ -5918,7 +5918,7 @@
             <a:pPr>
               <a:defRPr sz="1500" b="1">
                 <a:solidFill>
-                  <a:srgbClr val="10B981"/>
+                  <a:srgbClr val="059669"/>
                 </a:solidFill>
               </a:defRPr>
             </a:pPr>
@@ -5933,7 +5933,7 @@
               </a:spcBef>
               <a:defRPr sz="1200">
                 <a:solidFill>
-                  <a:srgbClr val="FFFFFF"/>
+                  <a:srgbClr val="0F172A"/>
                 </a:solidFill>
               </a:defRPr>
             </a:pPr>
@@ -5972,11 +5972,11 @@
             <a:avLst/>
           </a:prstGeom>
           <a:solidFill>
-            <a:srgbClr val="1A243C"/>
+            <a:srgbClr val="F0F9FF"/>
           </a:solidFill>
           <a:ln w="15240">
             <a:solidFill>
-              <a:srgbClr val="10B981"/>
+              <a:srgbClr val="BAE6FD"/>
             </a:solidFill>
           </a:ln>
         </p:spPr>
@@ -6027,7 +6027,7 @@
             <a:pPr algn="ctr">
               <a:defRPr sz="1300" b="1">
                 <a:solidFill>
-                  <a:srgbClr val="10B981"/>
+                  <a:srgbClr val="059669"/>
                 </a:solidFill>
               </a:defRPr>
             </a:pPr>
@@ -6078,7 +6078,7 @@
             <a:avLst/>
           </a:prstGeom>
           <a:solidFill>
-            <a:srgbClr val="0A0D14"/>
+            <a:srgbClr val="F8FAFC"/>
           </a:solidFill>
           <a:ln>
             <a:noFill/>
@@ -6131,7 +6131,7 @@
             <a:pPr>
               <a:defRPr sz="1100" b="1">
                 <a:solidFill>
-                  <a:srgbClr val="00F2FE"/>
+                  <a:srgbClr val="0284C7"/>
                 </a:solidFill>
                 <a:latin typeface="Segoe UI"/>
               </a:defRPr>
@@ -6167,7 +6167,7 @@
             <a:pPr algn="r">
               <a:defRPr sz="1100" b="1">
                 <a:solidFill>
-                  <a:srgbClr val="94A3B8"/>
+                  <a:srgbClr val="64748B"/>
                 </a:solidFill>
                 <a:latin typeface="Segoe UI"/>
               </a:defRPr>
@@ -6203,7 +6203,7 @@
             <a:pPr>
               <a:defRPr sz="2400" b="1">
                 <a:solidFill>
-                  <a:srgbClr val="FFFFFF"/>
+                  <a:srgbClr val="0F172A"/>
                 </a:solidFill>
                 <a:latin typeface="Segoe UI"/>
               </a:defRPr>
@@ -6229,11 +6229,11 @@
             <a:avLst/>
           </a:prstGeom>
           <a:solidFill>
-            <a:srgbClr val="131A2A"/>
+            <a:srgbClr val="FFFFFF"/>
           </a:solidFill>
           <a:ln w="15240">
             <a:solidFill>
-              <a:srgbClr val="26304A"/>
+              <a:srgbClr val="E2E8F0"/>
             </a:solidFill>
           </a:ln>
         </p:spPr>
@@ -6284,7 +6284,7 @@
             <a:pPr>
               <a:defRPr sz="1400" b="1">
                 <a:solidFill>
-                  <a:srgbClr val="10B981"/>
+                  <a:srgbClr val="059669"/>
                 </a:solidFill>
               </a:defRPr>
             </a:pPr>
@@ -6299,7 +6299,7 @@
               </a:spcBef>
               <a:defRPr sz="1200">
                 <a:solidFill>
-                  <a:srgbClr val="FFFFFF"/>
+                  <a:srgbClr val="0F172A"/>
                 </a:solidFill>
               </a:defRPr>
             </a:pPr>
@@ -6337,11 +6337,11 @@
             <a:avLst/>
           </a:prstGeom>
           <a:solidFill>
-            <a:srgbClr val="1A243C"/>
+            <a:srgbClr val="F0F9FF"/>
           </a:solidFill>
           <a:ln w="15240">
             <a:solidFill>
-              <a:srgbClr val="F59E0B"/>
+              <a:srgbClr val="BAE6FD"/>
             </a:solidFill>
           </a:ln>
         </p:spPr>
@@ -6392,7 +6392,7 @@
             <a:pPr>
               <a:defRPr sz="1400" b="1">
                 <a:solidFill>
-                  <a:srgbClr val="F59E0B"/>
+                  <a:srgbClr val="D97706"/>
                 </a:solidFill>
               </a:defRPr>
             </a:pPr>
@@ -6407,7 +6407,7 @@
               </a:spcBef>
               <a:defRPr sz="1200">
                 <a:solidFill>
-                  <a:srgbClr val="FFFFFF"/>
+                  <a:srgbClr val="0F172A"/>
                 </a:solidFill>
               </a:defRPr>
             </a:pPr>
@@ -6464,7 +6464,7 @@
             <a:avLst/>
           </a:prstGeom>
           <a:solidFill>
-            <a:srgbClr val="0A0D14"/>
+            <a:srgbClr val="F8FAFC"/>
           </a:solidFill>
           <a:ln>
             <a:noFill/>
@@ -6517,7 +6517,7 @@
             <a:pPr>
               <a:defRPr sz="1100" b="1">
                 <a:solidFill>
-                  <a:srgbClr val="00F2FE"/>
+                  <a:srgbClr val="0284C7"/>
                 </a:solidFill>
                 <a:latin typeface="Segoe UI"/>
               </a:defRPr>
@@ -6553,7 +6553,7 @@
             <a:pPr algn="r">
               <a:defRPr sz="1100" b="1">
                 <a:solidFill>
-                  <a:srgbClr val="94A3B8"/>
+                  <a:srgbClr val="64748B"/>
                 </a:solidFill>
                 <a:latin typeface="Segoe UI"/>
               </a:defRPr>
@@ -6589,7 +6589,7 @@
             <a:pPr>
               <a:defRPr sz="2400" b="1">
                 <a:solidFill>
-                  <a:srgbClr val="FFFFFF"/>
+                  <a:srgbClr val="0F172A"/>
                 </a:solidFill>
                 <a:latin typeface="Segoe UI"/>
               </a:defRPr>
@@ -6615,11 +6615,11 @@
             <a:avLst/>
           </a:prstGeom>
           <a:solidFill>
-            <a:srgbClr val="131A2A"/>
+            <a:srgbClr val="FFFFFF"/>
           </a:solidFill>
           <a:ln w="15240">
             <a:solidFill>
-              <a:srgbClr val="26304A"/>
+              <a:srgbClr val="E2E8F0"/>
             </a:solidFill>
           </a:ln>
         </p:spPr>
@@ -6694,7 +6694,7 @@
             <a:pPr>
               <a:defRPr sz="1100">
                 <a:solidFill>
-                  <a:srgbClr val="F59E0B"/>
+                  <a:srgbClr val="D97706"/>
                 </a:solidFill>
               </a:defRPr>
             </a:pPr>
@@ -6719,11 +6719,11 @@
             <a:avLst/>
           </a:prstGeom>
           <a:solidFill>
-            <a:srgbClr val="1A243C"/>
+            <a:srgbClr val="F0F9FF"/>
           </a:solidFill>
           <a:ln w="15240">
             <a:solidFill>
-              <a:srgbClr val="10B981"/>
+              <a:srgbClr val="BAE6FD"/>
             </a:solidFill>
           </a:ln>
         </p:spPr>
@@ -6798,7 +6798,7 @@
             <a:pPr>
               <a:defRPr sz="1100">
                 <a:solidFill>
-                  <a:srgbClr val="10B981"/>
+                  <a:srgbClr val="059669"/>
                 </a:solidFill>
               </a:defRPr>
             </a:pPr>
@@ -6841,7 +6841,7 @@
             <a:avLst/>
           </a:prstGeom>
           <a:solidFill>
-            <a:srgbClr val="0A0D14"/>
+            <a:srgbClr val="F8FAFC"/>
           </a:solidFill>
           <a:ln>
             <a:noFill/>
@@ -6894,7 +6894,7 @@
             <a:pPr>
               <a:defRPr sz="1100" b="1">
                 <a:solidFill>
-                  <a:srgbClr val="00F2FE"/>
+                  <a:srgbClr val="0284C7"/>
                 </a:solidFill>
                 <a:latin typeface="Segoe UI"/>
               </a:defRPr>
@@ -6930,7 +6930,7 @@
             <a:pPr algn="r">
               <a:defRPr sz="1100" b="1">
                 <a:solidFill>
-                  <a:srgbClr val="94A3B8"/>
+                  <a:srgbClr val="64748B"/>
                 </a:solidFill>
                 <a:latin typeface="Segoe UI"/>
               </a:defRPr>
@@ -6966,7 +6966,7 @@
             <a:pPr>
               <a:defRPr sz="2400" b="1">
                 <a:solidFill>
-                  <a:srgbClr val="FFFFFF"/>
+                  <a:srgbClr val="0F172A"/>
                 </a:solidFill>
                 <a:latin typeface="Segoe UI"/>
               </a:defRPr>
@@ -6992,11 +6992,11 @@
             <a:avLst/>
           </a:prstGeom>
           <a:solidFill>
-            <a:srgbClr val="131A2A"/>
+            <a:srgbClr val="FFFFFF"/>
           </a:solidFill>
           <a:ln w="15240">
             <a:solidFill>
-              <a:srgbClr val="26304A"/>
+              <a:srgbClr val="E2E8F0"/>
             </a:solidFill>
           </a:ln>
         </p:spPr>
@@ -7047,7 +7047,7 @@
             <a:pPr>
               <a:defRPr sz="1400" b="1">
                 <a:solidFill>
-                  <a:srgbClr val="FFFFFF"/>
+                  <a:srgbClr val="0F172A"/>
                 </a:solidFill>
               </a:defRPr>
             </a:pPr>
@@ -7062,7 +7062,7 @@
               </a:spcBef>
               <a:defRPr sz="1200">
                 <a:solidFill>
-                  <a:srgbClr val="FFFFFF"/>
+                  <a:srgbClr val="0F172A"/>
                 </a:solidFill>
               </a:defRPr>
             </a:pPr>
@@ -7099,11 +7099,11 @@
             <a:avLst/>
           </a:prstGeom>
           <a:solidFill>
-            <a:srgbClr val="131A2A"/>
+            <a:srgbClr val="FFFFFF"/>
           </a:solidFill>
           <a:ln w="15240">
             <a:solidFill>
-              <a:srgbClr val="26304A"/>
+              <a:srgbClr val="E2E8F0"/>
             </a:solidFill>
           </a:ln>
         </p:spPr>
@@ -7154,7 +7154,7 @@
             <a:pPr>
               <a:defRPr sz="1400" b="1">
                 <a:solidFill>
-                  <a:srgbClr val="FFFFFF"/>
+                  <a:srgbClr val="0F172A"/>
                 </a:solidFill>
               </a:defRPr>
             </a:pPr>
@@ -7169,7 +7169,7 @@
               </a:spcBef>
               <a:defRPr sz="1200">
                 <a:solidFill>
-                  <a:srgbClr val="FFFFFF"/>
+                  <a:srgbClr val="0F172A"/>
                 </a:solidFill>
               </a:defRPr>
             </a:pPr>
@@ -7206,11 +7206,11 @@
             <a:avLst/>
           </a:prstGeom>
           <a:solidFill>
-            <a:srgbClr val="1A243C"/>
+            <a:srgbClr val="F0F9FF"/>
           </a:solidFill>
           <a:ln w="15240">
             <a:solidFill>
-              <a:srgbClr val="26304A"/>
+              <a:srgbClr val="BAE6FD"/>
             </a:solidFill>
           </a:ln>
         </p:spPr>
@@ -7261,7 +7261,7 @@
             <a:pPr>
               <a:defRPr sz="1400" b="1">
                 <a:solidFill>
-                  <a:srgbClr val="00F2FE"/>
+                  <a:srgbClr val="0284C7"/>
                 </a:solidFill>
               </a:defRPr>
             </a:pPr>
@@ -7276,7 +7276,7 @@
               </a:spcBef>
               <a:defRPr sz="1200">
                 <a:solidFill>
-                  <a:srgbClr val="FFFFFF"/>
+                  <a:srgbClr val="0F172A"/>
                 </a:solidFill>
               </a:defRPr>
             </a:pPr>

</xml_diff>

<commit_message>
docs: bổ sung Slide 3 giải mã 4D RoPE, mốc t=10, 20... và cơ chế của BFL vào trọn bộ PPTX & HTML
</commit_message>
<xml_diff>
--- a/docs/TENDOO_AI_PHASE_3_EXECUTIVE_REPORT.pptx
+++ b/docs/TENDOO_AI_PHASE_3_EXECUTIVE_REPORT.pptx
@@ -15,6 +15,7 @@
     <p:sldId id="263" r:id="rId14"/>
     <p:sldId id="264" r:id="rId15"/>
     <p:sldId id="265" r:id="rId16"/>
+    <p:sldId id="266" r:id="rId17"/>
   </p:sldIdLst>
   <p:sldSz cx="12191695" cy="6858000" type="screen4x3"/>
   <p:notesSz cx="6858000" cy="9144000"/>
@@ -3688,7 +3689,7 @@
               </a:defRPr>
             </a:pPr>
             <a:r>
-              <a:t>TENDOO AI  |  ĐỀ XUẤT PHÊ DUYỆT &amp; KẾ HOẠCH</a:t>
+              <a:t>TENDOO AI  |  CHIẾN LƯỢC CHUYỂN GIAO TRI THỨC</a:t>
             </a:r>
           </a:p>
         </p:txBody>
@@ -3724,7 +3725,7 @@
               </a:defRPr>
             </a:pPr>
             <a:r>
-              <a:t>10 / 10</a:t>
+              <a:t>10 / 11</a:t>
             </a:r>
           </a:p>
         </p:txBody>
@@ -3752,7 +3753,497 @@
           <a:lstStyle/>
           <a:p>
             <a:pPr>
-              <a:defRPr sz="2400" b="1">
+              <a:defRPr sz="2300" b="1">
+                <a:solidFill>
+                  <a:srgbClr val="0F172A"/>
+                </a:solidFill>
+                <a:latin typeface="Segoe UI"/>
+              </a:defRPr>
+            </a:pPr>
+            <a:r>
+              <a:t>Chiến Lược Huấn Luyện LoRA DiT 4B Base (Phase 3 Master Roadmap)</a:t>
+            </a:r>
+          </a:p>
+        </p:txBody>
+      </p:sp>
+      <p:sp>
+        <p:nvSpPr>
+          <p:cNvPr id="6" name="Rounded Rectangle 5"/>
+          <p:cNvSpPr/>
+          <p:nvPr/>
+        </p:nvSpPr>
+        <p:spPr>
+          <a:xfrm>
+            <a:off x="731520" y="1645920"/>
+            <a:ext cx="3456432" cy="4389120"/>
+          </a:xfrm>
+          <a:prstGeom prst="roundRect">
+            <a:avLst/>
+          </a:prstGeom>
+          <a:solidFill>
+            <a:srgbClr val="FFFFFF"/>
+          </a:solidFill>
+          <a:ln w="15240">
+            <a:solidFill>
+              <a:srgbClr val="E2E8F0"/>
+            </a:solidFill>
+          </a:ln>
+        </p:spPr>
+        <p:style>
+          <a:lnRef idx="1">
+            <a:schemeClr val="accent1"/>
+          </a:lnRef>
+          <a:fillRef idx="3">
+            <a:schemeClr val="accent1"/>
+          </a:fillRef>
+          <a:effectRef idx="2">
+            <a:schemeClr val="accent1"/>
+          </a:effectRef>
+          <a:fontRef idx="minor">
+            <a:schemeClr val="lt1"/>
+          </a:fontRef>
+        </p:style>
+        <p:txBody>
+          <a:bodyPr rtlCol="0" anchor="ctr"/>
+          <a:lstStyle/>
+          <a:p>
+            <a:pPr algn="ctr"/>
+          </a:p>
+        </p:txBody>
+      </p:sp>
+      <p:sp>
+        <p:nvSpPr>
+          <p:cNvPr id="7" name="TextBox 6"/>
+          <p:cNvSpPr txBox="1"/>
+          <p:nvPr/>
+        </p:nvSpPr>
+        <p:spPr>
+          <a:xfrm>
+            <a:off x="914400" y="1828800"/>
+            <a:ext cx="3090672" cy="4023360"/>
+          </a:xfrm>
+          <a:prstGeom prst="rect">
+            <a:avLst/>
+          </a:prstGeom>
+          <a:noFill/>
+        </p:spPr>
+        <p:txBody>
+          <a:bodyPr wrap="square">
+            <a:spAutoFit/>
+          </a:bodyPr>
+          <a:lstStyle/>
+          <a:p>
+            <a:pPr>
+              <a:defRPr sz="1400" b="1">
+                <a:solidFill>
+                  <a:srgbClr val="0F172A"/>
+                </a:solidFill>
+              </a:defRPr>
+            </a:pPr>
+            <a:r>
+              <a:t>MILESTONE A (600 steps)</a:t>
+            </a:r>
+          </a:p>
+          <a:p>
+            <a:pPr>
+              <a:spcBef>
+                <a:spcPts val="1400"/>
+              </a:spcBef>
+              <a:defRPr sz="1200">
+                <a:solidFill>
+                  <a:srgbClr val="0F172A"/>
+                </a:solidFill>
+              </a:defRPr>
+            </a:pPr>
+            <a:r>
+              <a:t>Hòa Trộn 1 SP + 1 Headline</a:t>
+            </a:r>
+            <a:br/>
+            <a:r>
+              <a:t>• 500 mẫu (300 SP + 200 T2I)</a:t>
+            </a:r>
+            <a:br/>
+            <a:r>
+              <a:t>• Cân bằng Softmax giữa mỏ neo 4096 tokens và Headline.</a:t>
+            </a:r>
+            <a:br/>
+            <a:r>
+              <a:t>• Nghiệm thu: Headline 100%, SP &gt;= 98%.</a:t>
+            </a:r>
+          </a:p>
+        </p:txBody>
+      </p:sp>
+      <p:sp>
+        <p:nvSpPr>
+          <p:cNvPr id="8" name="Rounded Rectangle 7"/>
+          <p:cNvSpPr/>
+          <p:nvPr/>
+        </p:nvSpPr>
+        <p:spPr>
+          <a:xfrm>
+            <a:off x="4370832" y="1645920"/>
+            <a:ext cx="3456432" cy="4389120"/>
+          </a:xfrm>
+          <a:prstGeom prst="roundRect">
+            <a:avLst/>
+          </a:prstGeom>
+          <a:solidFill>
+            <a:srgbClr val="FFFFFF"/>
+          </a:solidFill>
+          <a:ln w="15240">
+            <a:solidFill>
+              <a:srgbClr val="E2E8F0"/>
+            </a:solidFill>
+          </a:ln>
+        </p:spPr>
+        <p:style>
+          <a:lnRef idx="1">
+            <a:schemeClr val="accent1"/>
+          </a:lnRef>
+          <a:fillRef idx="3">
+            <a:schemeClr val="accent1"/>
+          </a:fillRef>
+          <a:effectRef idx="2">
+            <a:schemeClr val="accent1"/>
+          </a:effectRef>
+          <a:fontRef idx="minor">
+            <a:schemeClr val="lt1"/>
+          </a:fontRef>
+        </p:style>
+        <p:txBody>
+          <a:bodyPr rtlCol="0" anchor="ctr"/>
+          <a:lstStyle/>
+          <a:p>
+            <a:pPr algn="ctr"/>
+          </a:p>
+        </p:txBody>
+      </p:sp>
+      <p:sp>
+        <p:nvSpPr>
+          <p:cNvPr id="9" name="TextBox 8"/>
+          <p:cNvSpPr txBox="1"/>
+          <p:nvPr/>
+        </p:nvSpPr>
+        <p:spPr>
+          <a:xfrm>
+            <a:off x="4553712" y="1828800"/>
+            <a:ext cx="3090672" cy="4023360"/>
+          </a:xfrm>
+          <a:prstGeom prst="rect">
+            <a:avLst/>
+          </a:prstGeom>
+          <a:noFill/>
+        </p:spPr>
+        <p:txBody>
+          <a:bodyPr wrap="square">
+            <a:spAutoFit/>
+          </a:bodyPr>
+          <a:lstStyle/>
+          <a:p>
+            <a:pPr>
+              <a:defRPr sz="1400" b="1">
+                <a:solidFill>
+                  <a:srgbClr val="0F172A"/>
+                </a:solidFill>
+              </a:defRPr>
+            </a:pPr>
+            <a:r>
+              <a:t>MILESTONE B (1,200 steps)</a:t>
+            </a:r>
+          </a:p>
+          <a:p>
+            <a:pPr>
+              <a:spcBef>
+                <a:spcPts val="1400"/>
+              </a:spcBef>
+              <a:defRPr sz="1200">
+                <a:solidFill>
+                  <a:srgbClr val="0F172A"/>
+                </a:solidFill>
+              </a:defRPr>
+            </a:pPr>
+            <a:r>
+              <a:t>Tách Kênh 2 Khối Text</a:t>
+            </a:r>
+            <a:br/>
+            <a:r>
+              <a:t>• 1,500 mẫu (900 SP + 600 T2I)</a:t>
+            </a:r>
+            <a:br/>
+            <a:r>
+              <a:t>• Kích hoạt phân luồng kênh t=20, triệt tiêu rò rỉ Ref-to-Ref.</a:t>
+            </a:r>
+            <a:br/>
+            <a:r>
+              <a:t>• Nghiệm thu: Cả 2 dòng chữ render đúng 100%.</a:t>
+            </a:r>
+          </a:p>
+        </p:txBody>
+      </p:sp>
+      <p:sp>
+        <p:nvSpPr>
+          <p:cNvPr id="10" name="Rounded Rectangle 9"/>
+          <p:cNvSpPr/>
+          <p:nvPr/>
+        </p:nvSpPr>
+        <p:spPr>
+          <a:xfrm>
+            <a:off x="8010144" y="1645920"/>
+            <a:ext cx="3456432" cy="4389120"/>
+          </a:xfrm>
+          <a:prstGeom prst="roundRect">
+            <a:avLst/>
+          </a:prstGeom>
+          <a:solidFill>
+            <a:srgbClr val="F0F9FF"/>
+          </a:solidFill>
+          <a:ln w="15240">
+            <a:solidFill>
+              <a:srgbClr val="BAE6FD"/>
+            </a:solidFill>
+          </a:ln>
+        </p:spPr>
+        <p:style>
+          <a:lnRef idx="1">
+            <a:schemeClr val="accent1"/>
+          </a:lnRef>
+          <a:fillRef idx="3">
+            <a:schemeClr val="accent1"/>
+          </a:fillRef>
+          <a:effectRef idx="2">
+            <a:schemeClr val="accent1"/>
+          </a:effectRef>
+          <a:fontRef idx="minor">
+            <a:schemeClr val="lt1"/>
+          </a:fontRef>
+        </p:style>
+        <p:txBody>
+          <a:bodyPr rtlCol="0" anchor="ctr"/>
+          <a:lstStyle/>
+          <a:p>
+            <a:pPr algn="ctr"/>
+          </a:p>
+        </p:txBody>
+      </p:sp>
+      <p:sp>
+        <p:nvSpPr>
+          <p:cNvPr id="11" name="TextBox 10"/>
+          <p:cNvSpPr txBox="1"/>
+          <p:nvPr/>
+        </p:nvSpPr>
+        <p:spPr>
+          <a:xfrm>
+            <a:off x="8193024" y="1828800"/>
+            <a:ext cx="3090672" cy="4023360"/>
+          </a:xfrm>
+          <a:prstGeom prst="rect">
+            <a:avLst/>
+          </a:prstGeom>
+          <a:noFill/>
+        </p:spPr>
+        <p:txBody>
+          <a:bodyPr wrap="square">
+            <a:spAutoFit/>
+          </a:bodyPr>
+          <a:lstStyle/>
+          <a:p>
+            <a:pPr>
+              <a:defRPr sz="1400" b="1">
+                <a:solidFill>
+                  <a:srgbClr val="0284C7"/>
+                </a:solidFill>
+              </a:defRPr>
+            </a:pPr>
+            <a:r>
+              <a:t>MILESTONE C (2,200 steps)</a:t>
+            </a:r>
+          </a:p>
+          <a:p>
+            <a:pPr>
+              <a:spcBef>
+                <a:spcPts val="1400"/>
+              </a:spcBef>
+              <a:defRPr sz="1200">
+                <a:solidFill>
+                  <a:srgbClr val="0F172A"/>
+                </a:solidFill>
+              </a:defRPr>
+            </a:pPr>
+            <a:r>
+              <a:t>Full 4-5 Slot Production</a:t>
+            </a:r>
+            <a:br/>
+            <a:r>
+              <a:t>• 2,500 mẫu toàn diện</a:t>
+            </a:r>
+            <a:br/>
+            <a:r>
+              <a:t>• Khóa cứng Attention 3-4 khối text (gồm Tier Cực Hạn 5-slot).</a:t>
+            </a:r>
+            <a:br/>
+            <a:r>
+              <a:t>• Nghiệm thu: Benchmark đạt &gt;= 95% tổng thể.</a:t>
+            </a:r>
+          </a:p>
+        </p:txBody>
+      </p:sp>
+    </p:spTree>
+  </p:cSld>
+  <p:clrMapOvr>
+    <a:masterClrMapping/>
+  </p:clrMapOvr>
+</p:sld>
+</file>
+
+<file path=ppt/slides/slide11.xml><?xml version="1.0" encoding="utf-8"?>
+<p:sld xmlns:a="http://schemas.openxmlformats.org/drawingml/2006/main" xmlns:p="http://schemas.openxmlformats.org/presentationml/2006/main" xmlns:r="http://schemas.openxmlformats.org/officeDocument/2006/relationships">
+  <p:cSld>
+    <p:spTree>
+      <p:nvGrpSpPr>
+        <p:cNvPr id="1" name=""/>
+        <p:cNvGrpSpPr/>
+        <p:nvPr/>
+      </p:nvGrpSpPr>
+      <p:grpSpPr/>
+      <p:sp>
+        <p:nvSpPr>
+          <p:cNvPr id="2" name="Rectangle 1"/>
+          <p:cNvSpPr/>
+          <p:nvPr/>
+        </p:nvSpPr>
+        <p:spPr>
+          <a:xfrm>
+            <a:off x="0" y="0"/>
+            <a:ext cx="12191695" cy="6858000"/>
+          </a:xfrm>
+          <a:prstGeom prst="rect">
+            <a:avLst/>
+          </a:prstGeom>
+          <a:solidFill>
+            <a:srgbClr val="F8FAFC"/>
+          </a:solidFill>
+          <a:ln>
+            <a:noFill/>
+          </a:ln>
+        </p:spPr>
+        <p:style>
+          <a:lnRef idx="1">
+            <a:schemeClr val="accent1"/>
+          </a:lnRef>
+          <a:fillRef idx="3">
+            <a:schemeClr val="accent1"/>
+          </a:fillRef>
+          <a:effectRef idx="2">
+            <a:schemeClr val="accent1"/>
+          </a:effectRef>
+          <a:fontRef idx="minor">
+            <a:schemeClr val="lt1"/>
+          </a:fontRef>
+        </p:style>
+        <p:txBody>
+          <a:bodyPr rtlCol="0" anchor="ctr"/>
+          <a:lstStyle/>
+          <a:p>
+            <a:pPr algn="ctr"/>
+          </a:p>
+        </p:txBody>
+      </p:sp>
+      <p:sp>
+        <p:nvSpPr>
+          <p:cNvPr id="3" name="TextBox 2"/>
+          <p:cNvSpPr txBox="1"/>
+          <p:nvPr/>
+        </p:nvSpPr>
+        <p:spPr>
+          <a:xfrm>
+            <a:off x="731520" y="365760"/>
+            <a:ext cx="7315200" cy="320040"/>
+          </a:xfrm>
+          <a:prstGeom prst="rect">
+            <a:avLst/>
+          </a:prstGeom>
+          <a:noFill/>
+        </p:spPr>
+        <p:txBody>
+          <a:bodyPr wrap="square">
+            <a:spAutoFit/>
+          </a:bodyPr>
+          <a:lstStyle/>
+          <a:p>
+            <a:pPr>
+              <a:defRPr sz="1100" b="1">
+                <a:solidFill>
+                  <a:srgbClr val="0284C7"/>
+                </a:solidFill>
+                <a:latin typeface="Segoe UI"/>
+              </a:defRPr>
+            </a:pPr>
+            <a:r>
+              <a:t>TENDOO AI  |  ĐỀ XUẤT PHÊ DUYỆT &amp; KẾ HOẠCH</a:t>
+            </a:r>
+          </a:p>
+        </p:txBody>
+      </p:sp>
+      <p:sp>
+        <p:nvSpPr>
+          <p:cNvPr id="4" name="TextBox 3"/>
+          <p:cNvSpPr txBox="1"/>
+          <p:nvPr/>
+        </p:nvSpPr>
+        <p:spPr>
+          <a:xfrm>
+            <a:off x="10515600" y="365760"/>
+            <a:ext cx="914400" cy="320040"/>
+          </a:xfrm>
+          <a:prstGeom prst="rect">
+            <a:avLst/>
+          </a:prstGeom>
+          <a:noFill/>
+        </p:spPr>
+        <p:txBody>
+          <a:bodyPr wrap="none">
+            <a:spAutoFit/>
+          </a:bodyPr>
+          <a:lstStyle/>
+          <a:p>
+            <a:pPr algn="r">
+              <a:defRPr sz="1100" b="1">
+                <a:solidFill>
+                  <a:srgbClr val="64748B"/>
+                </a:solidFill>
+                <a:latin typeface="Segoe UI"/>
+              </a:defRPr>
+            </a:pPr>
+            <a:r>
+              <a:t>11 / 11</a:t>
+            </a:r>
+          </a:p>
+        </p:txBody>
+      </p:sp>
+      <p:sp>
+        <p:nvSpPr>
+          <p:cNvPr id="5" name="TextBox 4"/>
+          <p:cNvSpPr txBox="1"/>
+          <p:nvPr/>
+        </p:nvSpPr>
+        <p:spPr>
+          <a:xfrm>
+            <a:off x="731520" y="685800"/>
+            <a:ext cx="10698480" cy="731520"/>
+          </a:xfrm>
+          <a:prstGeom prst="rect">
+            <a:avLst/>
+          </a:prstGeom>
+          <a:noFill/>
+        </p:spPr>
+        <p:txBody>
+          <a:bodyPr wrap="square">
+            <a:spAutoFit/>
+          </a:bodyPr>
+          <a:lstStyle/>
+          <a:p>
+            <a:pPr>
+              <a:defRPr sz="2300" b="1">
                 <a:solidFill>
                   <a:srgbClr val="0F172A"/>
                 </a:solidFill>
@@ -4123,7 +4614,7 @@
               </a:defRPr>
             </a:pPr>
             <a:r>
-              <a:t>02 / 10</a:t>
+              <a:t>02 / 11</a:t>
             </a:r>
           </a:p>
         </p:txBody>
@@ -4151,7 +4642,7 @@
           <a:lstStyle/>
           <a:p>
             <a:pPr>
-              <a:defRPr sz="2400" b="1">
+              <a:defRPr sz="2300" b="1">
                 <a:solidFill>
                   <a:srgbClr val="0F172A"/>
                 </a:solidFill>
@@ -4571,7 +5062,7 @@
               </a:defRPr>
             </a:pPr>
             <a:r>
-              <a:t>TENDOO AI  |  NGHIÊN CỨU LÝ THUYẾT &amp; PAPERS</a:t>
+              <a:t>TENDOO AI  |  CƠ CHẾ TOÁN HỌC CỐT LÕI</a:t>
             </a:r>
           </a:p>
         </p:txBody>
@@ -4607,7 +5098,7 @@
               </a:defRPr>
             </a:pPr>
             <a:r>
-              <a:t>03 / 10</a:t>
+              <a:t>03 / 11</a:t>
             </a:r>
           </a:p>
         </p:txBody>
@@ -4635,7 +5126,7 @@
           <a:lstStyle/>
           <a:p>
             <a:pPr>
-              <a:defRPr sz="2400" b="1">
+              <a:defRPr sz="2300" b="1">
                 <a:solidFill>
                   <a:srgbClr val="0F172A"/>
                 </a:solidFill>
@@ -4643,7 +5134,7 @@
               </a:defRPr>
             </a:pPr>
             <a:r>
-              <a:t>Bản Chất Gốc Rễ: Vì Sao Text Encoder Không Thể Vẽ Chữ Tiếng Việt?</a:t>
+              <a:t>Giải Mã Hệ Tọa Độ 4D RoPE &amp; Bí Mật Các Mốc Thời Gian (t=10, 20, 30...)</a:t>
             </a:r>
           </a:p>
         </p:txBody>
@@ -4657,7 +5148,7 @@
         <p:spPr>
           <a:xfrm>
             <a:off x="731520" y="1645920"/>
-            <a:ext cx="5257800" cy="4389120"/>
+            <a:ext cx="3456432" cy="4389120"/>
           </a:xfrm>
           <a:prstGeom prst="roundRect">
             <a:avLst/>
@@ -4701,8 +5192,8 @@
         </p:nvSpPr>
         <p:spPr>
           <a:xfrm>
-            <a:off x="960120" y="1874520"/>
-            <a:ext cx="4800600" cy="3931920"/>
+            <a:off x="914400" y="1828800"/>
+            <a:ext cx="3090672" cy="4023360"/>
           </a:xfrm>
           <a:prstGeom prst="rect">
             <a:avLst/>
@@ -4716,23 +5207,23 @@
           <a:lstStyle/>
           <a:p>
             <a:pPr>
-              <a:defRPr sz="1600" b="1">
-                <a:solidFill>
-                  <a:srgbClr val="D97706"/>
+              <a:defRPr sz="1300" b="1">
+                <a:solidFill>
+                  <a:srgbClr val="0284C7"/>
                 </a:solidFill>
                 <a:latin typeface="Segoe UI"/>
               </a:defRPr>
             </a:pPr>
             <a:r>
-              <a:t>❌ Điểm Mù Không Gian 2D của LLM</a:t>
+              <a:t>⏱️ 1. Mốc Thời Gian t=10, 20... Là Gì?</a:t>
             </a:r>
           </a:p>
           <a:p>
             <a:pPr>
               <a:spcBef>
-                <a:spcPts val="1400"/>
+                <a:spcPts val="1000"/>
               </a:spcBef>
-              <a:defRPr sz="1200">
+              <a:defRPr sz="1100">
                 <a:solidFill>
                   <a:srgbClr val="0F172A"/>
                 </a:solidFill>
@@ -4740,12 +5231,28 @@
               </a:defRPr>
             </a:pPr>
             <a:r>
-              <a:t>Các LLM ngôn ngữ thuần túy như Qwen3 chỉ xử lý chuỗi token 1D ngữ nghĩa. Chúng hoàn toàn không có biểu diễn tọa độ 2D về nét bút, vị trí dấu mũ (Â, Ô), dấu móc (Ơ, Ư) hay thanh điệu (Dấu hỏi, ngã, nặng).</a:t>
+              <a:t>FLUX.2 sử dụng hệ tọa độ 4 chiều: (t, h, w, l) để định vị từng token trong không gian và thời gian.</a:t>
             </a:r>
             <a:br/>
             <a:br/>
             <a:r>
-              <a:t>📌 Minh chứng từ BFL: Ở các phiên bản lớn hơn (9B / Dev), Black Forest Labs bắt buộc phải nâng cấp lên Vision-Language Model (VLM) đa phương thức để bù đắp điểm mù này!</a:t>
+              <a:t>• Canvas (Ảnh cần sinh): Đặt tại mốc hiện tại t = 0.0, trải rộng từ (0, 0) đến (H, W).</a:t>
+            </a:r>
+            <a:br/>
+            <a:r>
+              <a:t>• Ref Image 1 (Headline): Đặt tại mốc t = 10.0, tọa độ (0, 0).</a:t>
+            </a:r>
+            <a:br/>
+            <a:r>
+              <a:t>• Ref Image 2 (Subtitle): Đặt tại mốc t = 20.0, tọa độ (0, 0).</a:t>
+            </a:r>
+            <a:br/>
+            <a:r>
+              <a:t>• Ref Image 3 (CTA Badge): Đặt tại mốc t = 30.0, tọa độ (0, 0).</a:t>
+            </a:r>
+            <a:br/>
+            <a:r>
+              <a:t>• Ref Image 4 (Ảnh Sản Phẩm): Đặt tại mốc t = 40.0 hoặc 60.0.</a:t>
             </a:r>
           </a:p>
         </p:txBody>
@@ -4758,18 +5265,18 @@
         </p:nvSpPr>
         <p:spPr>
           <a:xfrm>
-            <a:off x="6172200" y="1645920"/>
-            <a:ext cx="5257800" cy="4389120"/>
+            <a:off x="4370832" y="1645920"/>
+            <a:ext cx="3456432" cy="4389120"/>
           </a:xfrm>
           <a:prstGeom prst="roundRect">
             <a:avLst/>
           </a:prstGeom>
           <a:solidFill>
-            <a:srgbClr val="F0F9FF"/>
+            <a:srgbClr val="FFFFFF"/>
           </a:solidFill>
           <a:ln w="15240">
             <a:solidFill>
-              <a:srgbClr val="BAE6FD"/>
+              <a:srgbClr val="E2E8F0"/>
             </a:solidFill>
           </a:ln>
         </p:spPr>
@@ -4803,8 +5310,8 @@
         </p:nvSpPr>
         <p:spPr>
           <a:xfrm>
-            <a:off x="6400800" y="1874520"/>
-            <a:ext cx="4800600" cy="3931920"/>
+            <a:off x="4553712" y="1828800"/>
+            <a:ext cx="3090672" cy="4023360"/>
           </a:xfrm>
           <a:prstGeom prst="rect">
             <a:avLst/>
@@ -4818,23 +5325,23 @@
           <a:lstStyle/>
           <a:p>
             <a:pPr>
-              <a:defRPr sz="1600" b="1">
-                <a:solidFill>
-                  <a:srgbClr val="0284C7"/>
+              <a:defRPr sz="1300" b="1">
+                <a:solidFill>
+                  <a:srgbClr val="7C3AED"/>
                 </a:solidFill>
                 <a:latin typeface="Segoe UI"/>
               </a:defRPr>
             </a:pPr>
             <a:r>
-              <a:t>❌ Hiện Tượng Xung Đột Biểu Diễn (Semantic Clash)</a:t>
+              <a:t>🎯 2. Tại Sao Phân Biệt Được Các Ảnh?</a:t>
             </a:r>
           </a:p>
           <a:p>
             <a:pPr>
               <a:spcBef>
-                <a:spcPts val="1400"/>
+                <a:spcPts val="1000"/>
               </a:spcBef>
-              <a:defRPr sz="1200">
+              <a:defRPr sz="1100">
                 <a:solidFill>
                   <a:srgbClr val="0F172A"/>
                 </a:solidFill>
@@ -4842,17 +5349,128 @@
               </a:defRPr>
             </a:pPr>
             <a:r>
-              <a:t>Khi prompt người dùng ghi rõ chữ tiếng Việt (ví dụ: 'vẽ chữ ÂM THANH ĐỈNH CAO'), Qwen3 cố gắng tự sinh chữ từ kiến thức tiền huấn luyện lỗi thời.</a:t>
+              <a:t>4D RoPE xoay vector truy vấn Q, K theo góc quay tần số: θ_i = 2000^(-2i/32).</a:t>
             </a:r>
             <a:br/>
             <a:br/>
             <a:r>
-              <a:t>Tín hiệu lỗi này xung đột trực tiếp với tín hiệu In-Context Glyph Bitmap chuẩn từ VAE, khiến DiT bị nhiễu loạn và làm vỡ nát nét chữ!</a:t>
+              <a:t>• Chống nhầm lẫn tọa độ: Dù mọi ảnh Ref đều bắt đầu từ góc (0, 0), mô hình không bao giờ bị đè pixel vì chúng nằm ở các 'khung thời gian t' hoàn toàn khác nhau!</a:t>
             </a:r>
             <a:br/>
             <a:br/>
             <a:r>
-              <a:t>👉 Quy Tắc Vàng: Text Prompt BẮT BUỘC LÀM SẠCH (chỉ tả bối cảnh &amp; ánh sáng), để Glyph chịu trách nhiệm 100% chính tả.</a:t>
+              <a:t>• Tính bất biến hoán vị (exp57): Thứ tự nối chuỗi cat() không quan trọng; chính giá trị t=10, 20 trong RoPE mới quyết định vai trò logic của từng ảnh!</a:t>
+            </a:r>
+          </a:p>
+        </p:txBody>
+      </p:sp>
+      <p:sp>
+        <p:nvSpPr>
+          <p:cNvPr id="10" name="Rounded Rectangle 9"/>
+          <p:cNvSpPr/>
+          <p:nvPr/>
+        </p:nvSpPr>
+        <p:spPr>
+          <a:xfrm>
+            <a:off x="8010144" y="1645920"/>
+            <a:ext cx="3456432" cy="4389120"/>
+          </a:xfrm>
+          <a:prstGeom prst="roundRect">
+            <a:avLst/>
+          </a:prstGeom>
+          <a:solidFill>
+            <a:srgbClr val="FFFFFF"/>
+          </a:solidFill>
+          <a:ln w="15240">
+            <a:solidFill>
+              <a:srgbClr val="E2E8F0"/>
+            </a:solidFill>
+          </a:ln>
+        </p:spPr>
+        <p:style>
+          <a:lnRef idx="1">
+            <a:schemeClr val="accent1"/>
+          </a:lnRef>
+          <a:fillRef idx="3">
+            <a:schemeClr val="accent1"/>
+          </a:fillRef>
+          <a:effectRef idx="2">
+            <a:schemeClr val="accent1"/>
+          </a:effectRef>
+          <a:fontRef idx="minor">
+            <a:schemeClr val="lt1"/>
+          </a:fontRef>
+        </p:style>
+        <p:txBody>
+          <a:bodyPr rtlCol="0" anchor="ctr"/>
+          <a:lstStyle/>
+          <a:p>
+            <a:pPr algn="ctr"/>
+          </a:p>
+        </p:txBody>
+      </p:sp>
+      <p:sp>
+        <p:nvSpPr>
+          <p:cNvPr id="11" name="TextBox 10"/>
+          <p:cNvSpPr txBox="1"/>
+          <p:nvPr/>
+        </p:nvSpPr>
+        <p:spPr>
+          <a:xfrm>
+            <a:off x="8193024" y="1828800"/>
+            <a:ext cx="3090672" cy="4023360"/>
+          </a:xfrm>
+          <a:prstGeom prst="rect">
+            <a:avLst/>
+          </a:prstGeom>
+          <a:noFill/>
+        </p:spPr>
+        <p:txBody>
+          <a:bodyPr wrap="square">
+            <a:spAutoFit/>
+          </a:bodyPr>
+          <a:lstStyle/>
+          <a:p>
+            <a:pPr>
+              <a:defRPr sz="1300" b="1">
+                <a:solidFill>
+                  <a:srgbClr val="059669"/>
+                </a:solidFill>
+                <a:latin typeface="Segoe UI"/>
+              </a:defRPr>
+            </a:pPr>
+            <a:r>
+              <a:t>🏛️ 3. Thiết Kế Gốc Của BFL &amp; Hạn Chế</a:t>
+            </a:r>
+          </a:p>
+          <a:p>
+            <a:pPr>
+              <a:spcBef>
+                <a:spcPts val="1000"/>
+              </a:spcBef>
+              <a:defRPr sz="1100">
+                <a:solidFill>
+                  <a:srgbClr val="0F172A"/>
+                </a:solidFill>
+                <a:latin typeface="Segoe UI"/>
+              </a:defRPr>
+            </a:pPr>
+            <a:r>
+              <a:t>Black Forest Labs (BFL) tiền huấn luyện FLUX.2 với các bước nhảy thời gian rời rạc: Δt = 10 x k (10.0, 20.0, 30.0).</a:t>
+            </a:r>
+            <a:br/>
+            <a:br/>
+            <a:r>
+              <a:t>• Kênh t=10.0 được tối ưu hóa sâu làm kênh tham chiếu chính.</a:t>
+            </a:r>
+            <a:br/>
+            <a:r>
+              <a:t>• Điểm nghẽn gốc: BFL chưa từng huấn luyện DiT đọc nhiều khối Glyph chữ đen trắng cùng lúc -&gt; Dẫn đến bão hòa và tràn kênh Attention ở t=20, 30.</a:t>
+            </a:r>
+            <a:br/>
+            <a:br/>
+            <a:r>
+              <a:t>👉 Đây chính là lý do Tendoo AI cần LoRA Phase 3 để tinh chỉnh ma trận Attention phân luồng!</a:t>
             </a:r>
           </a:p>
         </p:txBody>
@@ -4949,7 +5567,7 @@
               </a:defRPr>
             </a:pPr>
             <a:r>
-              <a:t>TENDOO AI  |  SÁNG KIẾN KỸ THUẬT</a:t>
+              <a:t>TENDOO AI  |  NGHIÊN CỨU LÝ THUYẾT &amp; PAPERS</a:t>
             </a:r>
           </a:p>
         </p:txBody>
@@ -4985,7 +5603,7 @@
               </a:defRPr>
             </a:pPr>
             <a:r>
-              <a:t>04 / 10</a:t>
+              <a:t>04 / 11</a:t>
             </a:r>
           </a:p>
         </p:txBody>
@@ -5013,7 +5631,7 @@
           <a:lstStyle/>
           <a:p>
             <a:pPr>
-              <a:defRPr sz="2400" b="1">
+              <a:defRPr sz="2300" b="1">
                 <a:solidFill>
                   <a:srgbClr val="0F172A"/>
                 </a:solidFill>
@@ -5021,7 +5639,7 @@
               </a:defRPr>
             </a:pPr>
             <a:r>
-              <a:t>Giải Pháp Đột Phá: Dynamic Glyph In-Context Conditioning</a:t>
+              <a:t>Bản Chất Gốc Rễ: Vì Sao Text Encoder Không Thể Vẽ Chữ Tiếng Việt?</a:t>
             </a:r>
           </a:p>
         </p:txBody>
@@ -5035,7 +5653,7 @@
         <p:spPr>
           <a:xfrm>
             <a:off x="731520" y="1645920"/>
-            <a:ext cx="3456432" cy="4389120"/>
+            <a:ext cx="5257800" cy="4389120"/>
           </a:xfrm>
           <a:prstGeom prst="roundRect">
             <a:avLst/>
@@ -5079,8 +5697,8 @@
         </p:nvSpPr>
         <p:spPr>
           <a:xfrm>
-            <a:off x="914400" y="1828800"/>
-            <a:ext cx="3090672" cy="4023360"/>
+            <a:off x="960120" y="1874520"/>
+            <a:ext cx="4800600" cy="3931920"/>
           </a:xfrm>
           <a:prstGeom prst="rect">
             <a:avLst/>
@@ -5094,15 +5712,15 @@
           <a:lstStyle/>
           <a:p>
             <a:pPr>
-              <a:defRPr sz="1400" b="1">
-                <a:solidFill>
-                  <a:srgbClr val="0284C7"/>
+              <a:defRPr sz="1600" b="1">
+                <a:solidFill>
+                  <a:srgbClr val="D97706"/>
                 </a:solidFill>
                 <a:latin typeface="Segoe UI"/>
               </a:defRPr>
             </a:pPr>
             <a:r>
-              <a:t>🔤 1. Render Glyph Đen-Trắng Chuẩn TTF</a:t>
+              <a:t>❌ Điểm Mù Không Gian 2D của LLM</a:t>
             </a:r>
           </a:p>
           <a:p>
@@ -5118,7 +5736,12 @@
               </a:defRPr>
             </a:pPr>
             <a:r>
-              <a:t>Dùng Python PIL/OpenCV render trực tiếp file font thương mại (Anton, BeVietnamPro, Pacifico, Playfair, Sedgwick). Đảm bảo 100% hình học Unicode tiếng Việt chuẩn xác trước khi nạp vào VAE.</a:t>
+              <a:t>Các LLM ngôn ngữ thuần túy như Qwen3 chỉ xử lý chuỗi token 1D ngữ nghĩa. Chúng hoàn toàn không có biểu diễn tọa độ 2D về nét bút, vị trí dấu mũ (Â, Ô), dấu móc (Ơ, Ư) hay thanh điệu (Dấu hỏi, ngã, nặng).</a:t>
+            </a:r>
+            <a:br/>
+            <a:br/>
+            <a:r>
+              <a:t>📌 Minh chứng từ BFL: Ở các phiên bản lớn hơn (9B / Dev), Black Forest Labs bắt buộc phải nâng cấp lên Vision-Language Model (VLM) đa phương thức để bù đắp điểm mù này!</a:t>
             </a:r>
           </a:p>
         </p:txBody>
@@ -5131,18 +5754,18 @@
         </p:nvSpPr>
         <p:spPr>
           <a:xfrm>
-            <a:off x="4370832" y="1645920"/>
-            <a:ext cx="3456432" cy="4389120"/>
+            <a:off x="6172200" y="1645920"/>
+            <a:ext cx="5257800" cy="4389120"/>
           </a:xfrm>
           <a:prstGeom prst="roundRect">
             <a:avLst/>
           </a:prstGeom>
           <a:solidFill>
-            <a:srgbClr val="FFFFFF"/>
+            <a:srgbClr val="F0F9FF"/>
           </a:solidFill>
           <a:ln w="15240">
             <a:solidFill>
-              <a:srgbClr val="E2E8F0"/>
+              <a:srgbClr val="BAE6FD"/>
             </a:solidFill>
           </a:ln>
         </p:spPr>
@@ -5176,8 +5799,8 @@
         </p:nvSpPr>
         <p:spPr>
           <a:xfrm>
-            <a:off x="4553712" y="1828800"/>
-            <a:ext cx="3090672" cy="4023360"/>
+            <a:off x="6400800" y="1874520"/>
+            <a:ext cx="4800600" cy="3931920"/>
           </a:xfrm>
           <a:prstGeom prst="rect">
             <a:avLst/>
@@ -5191,15 +5814,15 @@
           <a:lstStyle/>
           <a:p>
             <a:pPr>
-              <a:defRPr sz="1400" b="1">
-                <a:solidFill>
-                  <a:srgbClr val="059669"/>
+              <a:defRPr sz="1600" b="1">
+                <a:solidFill>
+                  <a:srgbClr val="0284C7"/>
                 </a:solidFill>
                 <a:latin typeface="Segoe UI"/>
               </a:defRPr>
             </a:pPr>
             <a:r>
-              <a:t>📐 2. Quy Luật Kích Thước Động (Dynamic Sizing)</a:t>
+              <a:t>❌ Hiện Tượng Xung Đột Biểu Diễn (Semantic Clash)</a:t>
             </a:r>
           </a:p>
           <a:p>
@@ -5215,104 +5838,17 @@
               </a:defRPr>
             </a:pPr>
             <a:r>
-              <a:t>Box tự động co giãn theo số từ và số dòng. Luôn đảm bảo Chiều cao &gt;= 160px (&gt;= 10 latent tokens) và Font size &gt;= 40px -&gt; Vượt xa ngưỡng nén 16x của VAE, tiết kiệm &gt;40% sequence length.</a:t>
-            </a:r>
-          </a:p>
-        </p:txBody>
-      </p:sp>
-      <p:sp>
-        <p:nvSpPr>
-          <p:cNvPr id="10" name="Rounded Rectangle 9"/>
-          <p:cNvSpPr/>
-          <p:nvPr/>
-        </p:nvSpPr>
-        <p:spPr>
-          <a:xfrm>
-            <a:off x="8010144" y="1645920"/>
-            <a:ext cx="3456432" cy="4389120"/>
-          </a:xfrm>
-          <a:prstGeom prst="roundRect">
-            <a:avLst/>
-          </a:prstGeom>
-          <a:solidFill>
-            <a:srgbClr val="FFFFFF"/>
-          </a:solidFill>
-          <a:ln w="15240">
-            <a:solidFill>
-              <a:srgbClr val="E2E8F0"/>
-            </a:solidFill>
-          </a:ln>
-        </p:spPr>
-        <p:style>
-          <a:lnRef idx="1">
-            <a:schemeClr val="accent1"/>
-          </a:lnRef>
-          <a:fillRef idx="3">
-            <a:schemeClr val="accent1"/>
-          </a:fillRef>
-          <a:effectRef idx="2">
-            <a:schemeClr val="accent1"/>
-          </a:effectRef>
-          <a:fontRef idx="minor">
-            <a:schemeClr val="lt1"/>
-          </a:fontRef>
-        </p:style>
-        <p:txBody>
-          <a:bodyPr rtlCol="0" anchor="ctr"/>
-          <a:lstStyle/>
-          <a:p>
-            <a:pPr algn="ctr"/>
-          </a:p>
-        </p:txBody>
-      </p:sp>
-      <p:sp>
-        <p:nvSpPr>
-          <p:cNvPr id="11" name="TextBox 10"/>
-          <p:cNvSpPr txBox="1"/>
-          <p:nvPr/>
-        </p:nvSpPr>
-        <p:spPr>
-          <a:xfrm>
-            <a:off x="8193024" y="1828800"/>
-            <a:ext cx="3090672" cy="4023360"/>
-          </a:xfrm>
-          <a:prstGeom prst="rect">
-            <a:avLst/>
-          </a:prstGeom>
-          <a:noFill/>
-        </p:spPr>
-        <p:txBody>
-          <a:bodyPr wrap="square">
-            <a:spAutoFit/>
-          </a:bodyPr>
-          <a:lstStyle/>
-          <a:p>
-            <a:pPr>
-              <a:defRPr sz="1400" b="1">
-                <a:solidFill>
-                  <a:srgbClr val="7C3AED"/>
-                </a:solidFill>
-                <a:latin typeface="Segoe UI"/>
-              </a:defRPr>
-            </a:pPr>
-            <a:r>
-              <a:t>🎨 3. Đa Dạng Font Chuẩn 5 Ngành Hàng</a:t>
-            </a:r>
-          </a:p>
-          <a:p>
-            <a:pPr>
-              <a:spcBef>
-                <a:spcPts val="1400"/>
-              </a:spcBef>
-              <a:defRPr sz="1200">
-                <a:solidFill>
-                  <a:srgbClr val="0F172A"/>
-                </a:solidFill>
-                <a:latin typeface="Segoe UI"/>
-              </a:defRPr>
-            </a:pPr>
-            <a:r>
-              <a:t>Ánh xạ 1:1 theo Domain: F&amp;B (Khắc gỗ/Neon Sedgwick), Tech (Kim loại Anton), Fashion (Gold Serif Playfair), Spa (Cursive mềm mại), FMCG (Pop-art dập nổi Gotham/Oswald).</a:t>
+              <a:t>Khi prompt người dùng ghi rõ chữ tiếng Việt (ví dụ: 'vẽ chữ ÂM THANH ĐỈNH CAO'), Qwen3 cố gắng tự sinh chữ từ kiến thức tiền huấn luyện lỗi thời.</a:t>
+            </a:r>
+            <a:br/>
+            <a:br/>
+            <a:r>
+              <a:t>Tín hiệu lỗi này xung đột trực tiếp với tín hiệu In-Context Glyph Bitmap chuẩn từ VAE, khiến DiT bị nhiễu loạn và làm vỡ nát nét chữ!</a:t>
+            </a:r>
+            <a:br/>
+            <a:br/>
+            <a:r>
+              <a:t>👉 Quy Tắc Vàng: Text Prompt BẮT BUỘC LÀM SẠCH (chỉ tả bối cảnh &amp; ánh sáng), để Glyph chịu trách nhiệm 100% chính tả.</a:t>
             </a:r>
           </a:p>
         </p:txBody>
@@ -5409,7 +5945,7 @@
               </a:defRPr>
             </a:pPr>
             <a:r>
-              <a:t>TENDOO AI  |  KẾT QUẢ THỰC NGHIỆM ĐỈNH CAO</a:t>
+              <a:t>TENDOO AI  |  SÁNG KIẾN KỸ THUẬT</a:t>
             </a:r>
           </a:p>
         </p:txBody>
@@ -5445,7 +5981,7 @@
               </a:defRPr>
             </a:pPr>
             <a:r>
-              <a:t>05 / 10</a:t>
+              <a:t>05 / 11</a:t>
             </a:r>
           </a:p>
         </p:txBody>
@@ -5473,7 +6009,7 @@
           <a:lstStyle/>
           <a:p>
             <a:pPr>
-              <a:defRPr sz="2400" b="1">
+              <a:defRPr sz="2300" b="1">
                 <a:solidFill>
                   <a:srgbClr val="0F172A"/>
                 </a:solidFill>
@@ -5481,7 +6017,7 @@
               </a:defRPr>
             </a:pPr>
             <a:r>
-              <a:t>Showcase 1: Khắc Phục Nén VAE Với Bài Thơ Dài (28 Từ, 119 Ký Tự)</a:t>
+              <a:t>Giải Pháp Đột Phá: Dynamic Glyph In-Context Conditioning</a:t>
             </a:r>
           </a:p>
         </p:txBody>
@@ -5495,7 +6031,7 @@
         <p:spPr>
           <a:xfrm>
             <a:off x="731520" y="1645920"/>
-            <a:ext cx="5257800" cy="4389120"/>
+            <a:ext cx="3456432" cy="4389120"/>
           </a:xfrm>
           <a:prstGeom prst="roundRect">
             <a:avLst/>
@@ -5539,8 +6075,8 @@
         </p:nvSpPr>
         <p:spPr>
           <a:xfrm>
-            <a:off x="960120" y="1874520"/>
-            <a:ext cx="4800600" cy="3931920"/>
+            <a:off x="914400" y="1828800"/>
+            <a:ext cx="3090672" cy="4023360"/>
           </a:xfrm>
           <a:prstGeom prst="rect">
             <a:avLst/>
@@ -5554,39 +6090,31 @@
           <a:lstStyle/>
           <a:p>
             <a:pPr>
-              <a:defRPr sz="1500" b="1">
+              <a:defRPr sz="1400" b="1">
                 <a:solidFill>
                   <a:srgbClr val="0284C7"/>
                 </a:solidFill>
-              </a:defRPr>
-            </a:pPr>
-            <a:r>
-              <a:t>🏆 ĐỘT PHÁ EXP54: 100% CHÍNH TẢ BÀI THƠ 4 CÂU</a:t>
+                <a:latin typeface="Segoe UI"/>
+              </a:defRPr>
+            </a:pPr>
+            <a:r>
+              <a:t>🔤 1. Render Glyph Đen-Trắng Chuẩn TTF</a:t>
             </a:r>
           </a:p>
           <a:p>
             <a:pPr>
               <a:spcBef>
-                <a:spcPts val="1200"/>
+                <a:spcPts val="1400"/>
               </a:spcBef>
               <a:defRPr sz="1200">
                 <a:solidFill>
                   <a:srgbClr val="0F172A"/>
                 </a:solidFill>
-              </a:defRPr>
-            </a:pPr>
-            <a:r>
-              <a:t>• Lầm tưởng ban đầu (exp52): Cho rằng mô hình Base 4B bị giới hạn trí nhớ không thể sinh được bài thơ dài 4 câu.</a:t>
-            </a:r>
-            <a:br/>
-            <a:br/>
-            <a:r>
-              <a:t>• Bản chất thật: Do ép 4 dòng vào Box nhỏ (512x224px) khiến font size bị co xuống 18px -&gt; sụp đổ đặc trưng khi VAE nén 16x.</a:t>
-            </a:r>
-            <a:br/>
-            <a:br/>
-            <a:r>
-              <a:t>• Thành công rực rỡ (exp54): Khi mở rộng Box lên 896x512px (font size ~46px), FLUX 4B sinh ảnh KHÔNG SAI MỘT DẤU NÀO cả bài thơ 4 câu 'Tây Tiến' khắc chìm mạ vàng trên vách đá sa thạch!</a:t>
+                <a:latin typeface="Segoe UI"/>
+              </a:defRPr>
+            </a:pPr>
+            <a:r>
+              <a:t>Dùng Python PIL/OpenCV render trực tiếp file font thương mại (Anton, BeVietnamPro, Pacifico, Playfair, Sedgwick). Đảm bảo 100% hình học Unicode tiếng Việt chuẩn xác trước khi nạp vào VAE.</a:t>
             </a:r>
           </a:p>
         </p:txBody>
@@ -5599,18 +6127,18 @@
         </p:nvSpPr>
         <p:spPr>
           <a:xfrm>
-            <a:off x="6172200" y="1645920"/>
-            <a:ext cx="5257800" cy="4389120"/>
+            <a:off x="4370832" y="1645920"/>
+            <a:ext cx="3456432" cy="4389120"/>
           </a:xfrm>
           <a:prstGeom prst="roundRect">
             <a:avLst/>
           </a:prstGeom>
           <a:solidFill>
-            <a:srgbClr val="F0F9FF"/>
+            <a:srgbClr val="FFFFFF"/>
           </a:solidFill>
           <a:ln w="15240">
             <a:solidFill>
-              <a:srgbClr val="BAE6FD"/>
+              <a:srgbClr val="E2E8F0"/>
             </a:solidFill>
           </a:ln>
         </p:spPr>
@@ -5644,8 +6172,8 @@
         </p:nvSpPr>
         <p:spPr>
           <a:xfrm>
-            <a:off x="6446520" y="3291840"/>
-            <a:ext cx="4709160" cy="1371600"/>
+            <a:off x="4553712" y="1828800"/>
+            <a:ext cx="3090672" cy="4023360"/>
           </a:xfrm>
           <a:prstGeom prst="rect">
             <a:avLst/>
@@ -5658,23 +6186,129 @@
           </a:bodyPr>
           <a:lstStyle/>
           <a:p>
-            <a:pPr algn="ctr">
-              <a:defRPr sz="1300" b="1">
-                <a:solidFill>
-                  <a:srgbClr val="0284C7"/>
-                </a:solidFill>
-              </a:defRPr>
-            </a:pPr>
-            <a:r>
-              <a:t>📸 [CHÈN ẢNH EXP54 TẠI ĐÂY]</a:t>
-            </a:r>
-            <a:br/>
-            <a:r>
-              <a:t>File: tay_tien_hires_glyph_4lines.png</a:t>
-            </a:r>
-            <a:br/>
-            <a:r>
-              <a:t>(Vách đá sa thạch mạ vàng 4 câu thơ Tây Tiến)</a:t>
+            <a:pPr>
+              <a:defRPr sz="1400" b="1">
+                <a:solidFill>
+                  <a:srgbClr val="059669"/>
+                </a:solidFill>
+                <a:latin typeface="Segoe UI"/>
+              </a:defRPr>
+            </a:pPr>
+            <a:r>
+              <a:t>📐 2. Quy Luật Kích Thước Động (Dynamic Sizing)</a:t>
+            </a:r>
+          </a:p>
+          <a:p>
+            <a:pPr>
+              <a:spcBef>
+                <a:spcPts val="1400"/>
+              </a:spcBef>
+              <a:defRPr sz="1200">
+                <a:solidFill>
+                  <a:srgbClr val="0F172A"/>
+                </a:solidFill>
+                <a:latin typeface="Segoe UI"/>
+              </a:defRPr>
+            </a:pPr>
+            <a:r>
+              <a:t>Box tự động co giãn theo số từ và số dòng. Luôn đảm bảo Chiều cao &gt;= 160px (&gt;= 10 latent tokens) và Font size &gt;= 40px -&gt; Vượt xa ngưỡng nén 16x của VAE, tiết kiệm &gt;40% sequence length.</a:t>
+            </a:r>
+          </a:p>
+        </p:txBody>
+      </p:sp>
+      <p:sp>
+        <p:nvSpPr>
+          <p:cNvPr id="10" name="Rounded Rectangle 9"/>
+          <p:cNvSpPr/>
+          <p:nvPr/>
+        </p:nvSpPr>
+        <p:spPr>
+          <a:xfrm>
+            <a:off x="8010144" y="1645920"/>
+            <a:ext cx="3456432" cy="4389120"/>
+          </a:xfrm>
+          <a:prstGeom prst="roundRect">
+            <a:avLst/>
+          </a:prstGeom>
+          <a:solidFill>
+            <a:srgbClr val="FFFFFF"/>
+          </a:solidFill>
+          <a:ln w="15240">
+            <a:solidFill>
+              <a:srgbClr val="E2E8F0"/>
+            </a:solidFill>
+          </a:ln>
+        </p:spPr>
+        <p:style>
+          <a:lnRef idx="1">
+            <a:schemeClr val="accent1"/>
+          </a:lnRef>
+          <a:fillRef idx="3">
+            <a:schemeClr val="accent1"/>
+          </a:fillRef>
+          <a:effectRef idx="2">
+            <a:schemeClr val="accent1"/>
+          </a:effectRef>
+          <a:fontRef idx="minor">
+            <a:schemeClr val="lt1"/>
+          </a:fontRef>
+        </p:style>
+        <p:txBody>
+          <a:bodyPr rtlCol="0" anchor="ctr"/>
+          <a:lstStyle/>
+          <a:p>
+            <a:pPr algn="ctr"/>
+          </a:p>
+        </p:txBody>
+      </p:sp>
+      <p:sp>
+        <p:nvSpPr>
+          <p:cNvPr id="11" name="TextBox 10"/>
+          <p:cNvSpPr txBox="1"/>
+          <p:nvPr/>
+        </p:nvSpPr>
+        <p:spPr>
+          <a:xfrm>
+            <a:off x="8193024" y="1828800"/>
+            <a:ext cx="3090672" cy="4023360"/>
+          </a:xfrm>
+          <a:prstGeom prst="rect">
+            <a:avLst/>
+          </a:prstGeom>
+          <a:noFill/>
+        </p:spPr>
+        <p:txBody>
+          <a:bodyPr wrap="square">
+            <a:spAutoFit/>
+          </a:bodyPr>
+          <a:lstStyle/>
+          <a:p>
+            <a:pPr>
+              <a:defRPr sz="1400" b="1">
+                <a:solidFill>
+                  <a:srgbClr val="7C3AED"/>
+                </a:solidFill>
+                <a:latin typeface="Segoe UI"/>
+              </a:defRPr>
+            </a:pPr>
+            <a:r>
+              <a:t>🎨 3. Đa Dạng Font Chuẩn 5 Ngành Hàng</a:t>
+            </a:r>
+          </a:p>
+          <a:p>
+            <a:pPr>
+              <a:spcBef>
+                <a:spcPts val="1400"/>
+              </a:spcBef>
+              <a:defRPr sz="1200">
+                <a:solidFill>
+                  <a:srgbClr val="0F172A"/>
+                </a:solidFill>
+                <a:latin typeface="Segoe UI"/>
+              </a:defRPr>
+            </a:pPr>
+            <a:r>
+              <a:t>Ánh xạ 1:1 theo Domain: F&amp;B (Khắc gỗ/Neon Sedgwick), Tech (Kim loại Anton), Fashion (Gold Serif Playfair), Spa (Cursive mềm mại), FMCG (Pop-art dập nổi Gotham/Oswald).</a:t>
             </a:r>
           </a:p>
         </p:txBody>
@@ -5771,7 +6405,7 @@
               </a:defRPr>
             </a:pPr>
             <a:r>
-              <a:t>TENDOO AI  |  NĂNG LỰC QUANG HỌC &amp; CHẤT LIỆU</a:t>
+              <a:t>TENDOO AI  |  KẾT QUẢ THỰC NGHIỆM ĐỈNH CAO</a:t>
             </a:r>
           </a:p>
         </p:txBody>
@@ -5807,7 +6441,7 @@
               </a:defRPr>
             </a:pPr>
             <a:r>
-              <a:t>06 / 10</a:t>
+              <a:t>06 / 11</a:t>
             </a:r>
           </a:p>
         </p:txBody>
@@ -5835,7 +6469,7 @@
           <a:lstStyle/>
           <a:p>
             <a:pPr>
-              <a:defRPr sz="2400" b="1">
+              <a:defRPr sz="2300" b="1">
                 <a:solidFill>
                   <a:srgbClr val="0F172A"/>
                 </a:solidFill>
@@ -5843,7 +6477,7 @@
               </a:defRPr>
             </a:pPr>
             <a:r>
-              <a:t>Showcase 2: Biến Hóa Chất Liệu 3D &amp; Hòa Trộn Sản Phẩm Thật</a:t>
+              <a:t>Showcase 1: Khắc Phục Nén VAE Với Bài Thơ Dài (28 Từ, 119 Ký Tự)</a:t>
             </a:r>
           </a:p>
         </p:txBody>
@@ -5918,12 +6552,12 @@
             <a:pPr>
               <a:defRPr sz="1500" b="1">
                 <a:solidFill>
-                  <a:srgbClr val="059669"/>
-                </a:solidFill>
-              </a:defRPr>
-            </a:pPr>
-            <a:r>
-              <a:t>💎 ĐỊNH LUẬT BẢO TOÀN ĐƠN KHỐI (exp50 - exp51)</a:t>
+                  <a:srgbClr val="0284C7"/>
+                </a:solidFill>
+              </a:defRPr>
+            </a:pPr>
+            <a:r>
+              <a:t>🏆 ĐỘT PHÁ EXP54: 100% CHÍNH TẢ 4 CÂU THƠ</a:t>
             </a:r>
           </a:p>
           <a:p>
@@ -5938,21 +6572,17 @@
               </a:defRPr>
             </a:pPr>
             <a:r>
-              <a:t>• Khi chỉ có 1 Khối Text (t=10.0) + 1 Ảnh Sản Phẩm (t=60.0):</a:t>
-            </a:r>
-            <a:br/>
-            <a:r>
-              <a:t>  Chữ LUÔN LUÔN ĐƯỢC GIỮ ĐẸP VÀ CHUẨN XÁC 100%, tự động biến hóa mượt mà theo chất liệu trong Prompt (chữ vàng 3D dập nổi, đèn neon phát quang, đổ bóng studio).</a:t>
+              <a:t>• Lầm tưởng ban đầu (exp52): Cho rằng mô hình Base 4B bị giới hạn trí nhớ không thể sinh được bài thơ dài 4 câu.</a:t>
             </a:r>
             <a:br/>
             <a:br/>
             <a:r>
-              <a:t>• Ảnh sản phẩm thật (4096 tokens) được bảo tồn 100% góc nhìn, ánh sáng và chi tiết thương hiệu.</a:t>
+              <a:t>• Bản chất thật: Do ép 4 dòng vào Box nhỏ (512x224px) khiến font size bị co xuống 18px -&gt; sụp đổ đặc trưng khi VAE nén 16x.</a:t>
             </a:r>
             <a:br/>
             <a:br/>
             <a:r>
-              <a:t>👉 Khẳng định: Mô hình Base 4B đã hoàn toàn sẵn sàng cho bài toán 1 Text + 1 Sản phẩm!</a:t>
+              <a:t>• Thành công rực rỡ (exp54): Khi mở rộng Box lên 896x512px (font size ~46px), FLUX 4B sinh ảnh KHÔNG SAI MỘT DẤU NÀO cả bài thơ 4 câu 'Tây Tiến' khắc chìm mạ vàng trên vách đá sa thạch!</a:t>
             </a:r>
           </a:p>
         </p:txBody>
@@ -6027,20 +6657,20 @@
             <a:pPr algn="ctr">
               <a:defRPr sz="1300" b="1">
                 <a:solidFill>
-                  <a:srgbClr val="059669"/>
-                </a:solidFill>
-              </a:defRPr>
-            </a:pPr>
-            <a:r>
-              <a:t>📸 [CHÈN ẢNH EXP50/51 TẠI ĐÂY]</a:t>
+                  <a:srgbClr val="0284C7"/>
+                </a:solidFill>
+              </a:defRPr>
+            </a:pPr>
+            <a:r>
+              <a:t>📸 [CHÈN ẢNH EXP54 TẠI ĐÂY]</a:t>
             </a:r>
             <a:br/>
             <a:r>
-              <a:t>File: poster_headphone_3d_gold.png</a:t>
+              <a:t>File: tay_tien_hires_glyph_4lines.png</a:t>
             </a:r>
             <a:br/>
             <a:r>
-              <a:t>(Tai nghe thật + Tiêu đề vàng dập nổi 3D)</a:t>
+              <a:t>(Vách đá sa thạch mạ vàng 4 câu thơ Tây Tiến)</a:t>
             </a:r>
           </a:p>
         </p:txBody>
@@ -6137,7 +6767,7 @@
               </a:defRPr>
             </a:pPr>
             <a:r>
-              <a:t>TENDOO AI  |  BẢN CHẤT CƠ CHẾ SOFTMAX</a:t>
+              <a:t>TENDOO AI  |  NĂNG LỰC QUANG HỌC &amp; CHẤT LIỆU</a:t>
             </a:r>
           </a:p>
         </p:txBody>
@@ -6173,7 +6803,7 @@
               </a:defRPr>
             </a:pPr>
             <a:r>
-              <a:t>07 / 10</a:t>
+              <a:t>07 / 11</a:t>
             </a:r>
           </a:p>
         </p:txBody>
@@ -6201,7 +6831,7 @@
           <a:lstStyle/>
           <a:p>
             <a:pPr>
-              <a:defRPr sz="2400" b="1">
+              <a:defRPr sz="2300" b="1">
                 <a:solidFill>
                   <a:srgbClr val="0F172A"/>
                 </a:solidFill>
@@ -6209,7 +6839,7 @@
               </a:defRPr>
             </a:pPr>
             <a:r>
-              <a:t>Thách Thức Kỹ Thuật: Trạng Thái Cô Lập (t&lt;=40) vs Cạnh Tranh Đồng Thời</a:t>
+              <a:t>Showcase 2: Biến Hóa Chất Liệu 3D &amp; Hòa Trộn Sản Phẩm Thật</a:t>
             </a:r>
           </a:p>
         </p:txBody>
@@ -6282,20 +6912,20 @@
           <a:lstStyle/>
           <a:p>
             <a:pPr>
-              <a:defRPr sz="1400" b="1">
+              <a:defRPr sz="1500" b="1">
                 <a:solidFill>
                   <a:srgbClr val="059669"/>
                 </a:solidFill>
               </a:defRPr>
             </a:pPr>
             <a:r>
-              <a:t>🟢 TRẠNG THÁI CÔ LẬP (PROBE SUITE 1)</a:t>
+              <a:t>💎 ĐỊNH LUẬT BẢO TOÀN ĐƠN KHỐI (exp50 - exp51)</a:t>
             </a:r>
           </a:p>
           <a:p>
             <a:pPr>
               <a:spcBef>
-                <a:spcPts val="1000"/>
+                <a:spcPts val="1200"/>
               </a:spcBef>
               <a:defRPr sz="1200">
                 <a:solidFill>
@@ -6304,20 +6934,21 @@
               </a:defRPr>
             </a:pPr>
             <a:r>
-              <a:t>• Khi chạy từng kênh đơn lẻ:</a:t>
+              <a:t>• Khi chỉ có 1 Khối Text (t=10.0) + 1 Ảnh Sản Phẩm (t=60.0):</a:t>
             </a:r>
             <a:br/>
             <a:r>
-              <a:t>  Kênh t=10.0, 20.0, 30.0, 40.0 ĐỀU VẼ CHỮ 3D ĐẸP 100% CHUẨN XÁC.</a:t>
-            </a:r>
-            <a:br/>
-            <a:r>
-              <a:t>• Chỉ bắt đầu suy hao góc quay RoPE tại t &gt;= 50.0.</a:t>
+              <a:t>  Chữ LUÔN LUÔN ĐƯỢC GIỮ ĐẸP VÀ CHUẨN XÁC 100%, tự động biến hóa mượt mà theo chất liệu trong Prompt (chữ vàng 3D dập nổi, đèn neon phát quang, đổ bóng studio).</a:t>
             </a:r>
             <a:br/>
             <a:br/>
             <a:r>
-              <a:t>👉 Ý nghĩa: Mô hình Base ĐÃ CÓ SẴN năng lực biểu diễn chữ ở dải t &lt;= 40.0!</a:t>
+              <a:t>• Ảnh sản phẩm thật (4096 tokens) được bảo tồn 100% góc nhìn, ánh sáng và chi tiết thương hiệu.</a:t>
+            </a:r>
+            <a:br/>
+            <a:br/>
+            <a:r>
+              <a:t>👉 Khẳng định: Mô hình Base 4B đã hoàn toàn sẵn sàng cho bài toán 1 Text + 1 Sản phẩm!</a:t>
             </a:r>
           </a:p>
         </p:txBody>
@@ -6375,8 +7006,8 @@
         </p:nvSpPr>
         <p:spPr>
           <a:xfrm>
-            <a:off x="6400800" y="1874520"/>
-            <a:ext cx="4800600" cy="3931920"/>
+            <a:off x="6446520" y="3291840"/>
+            <a:ext cx="4709160" cy="1371600"/>
           </a:xfrm>
           <a:prstGeom prst="rect">
             <a:avLst/>
@@ -6389,44 +7020,23 @@
           </a:bodyPr>
           <a:lstStyle/>
           <a:p>
-            <a:pPr>
-              <a:defRPr sz="1400" b="1">
-                <a:solidFill>
-                  <a:srgbClr val="D97706"/>
-                </a:solidFill>
-              </a:defRPr>
-            </a:pPr>
-            <a:r>
-              <a:t>🔴 TRẠNG THÁI CẠNH TRANH (PROBE SUITE 2)</a:t>
-            </a:r>
-          </a:p>
-          <a:p>
-            <a:pPr>
-              <a:spcBef>
-                <a:spcPts val="1000"/>
-              </a:spcBef>
-              <a:defRPr sz="1200">
-                <a:solidFill>
-                  <a:srgbClr val="0F172A"/>
-                </a:solidFill>
-              </a:defRPr>
-            </a:pPr>
-            <a:r>
-              <a:t>• Khi đưa đồng thời 3-4 Slot:</a:t>
+            <a:pPr algn="ctr">
+              <a:defRPr sz="1300" b="1">
+                <a:solidFill>
+                  <a:srgbClr val="059669"/>
+                </a:solidFill>
+              </a:defRPr>
+            </a:pPr>
+            <a:r>
+              <a:t>📸 [CHÈN ẢNH EXP50/51 TẠI ĐÂY]</a:t>
             </a:r>
             <a:br/>
             <a:r>
-              <a:t>  Attention Heads bị hiện tượng Tranh chấp &amp; Tràn kênh (Cross-Slot Bleeding) -&gt; Slot giữa bị đè mất.</a:t>
+              <a:t>File: poster_headphone_3d_gold.png</a:t>
             </a:r>
             <a:br/>
-            <a:br/>
-            <a:r>
-              <a:t>• Ảnh sản phẩm (4096 tokens) luôn thắng thế nhờ Token Mass Dominance.</a:t>
-            </a:r>
-            <a:br/>
-            <a:br/>
-            <a:r>
-              <a:t>👉 Mục tiêu LoRA Phase 3: Dạy DiT phân luồng Attention độc lập giữa các slot!</a:t>
+            <a:r>
+              <a:t>(Tai nghe thật + Tiêu đề vàng dập nổi 3D)</a:t>
             </a:r>
           </a:p>
         </p:txBody>
@@ -6523,7 +7133,7 @@
               </a:defRPr>
             </a:pPr>
             <a:r>
-              <a:t>TENDOO AI  |  BẰNG CHỨNG THỰC NGHIỆM TRỰC QUAN</a:t>
+              <a:t>TENDOO AI  |  BẢN CHẤT CƠ CHẾ SOFTMAX</a:t>
             </a:r>
           </a:p>
         </p:txBody>
@@ -6559,7 +7169,7 @@
               </a:defRPr>
             </a:pPr>
             <a:r>
-              <a:t>08 / 10</a:t>
+              <a:t>08 / 11</a:t>
             </a:r>
           </a:p>
         </p:txBody>
@@ -6587,7 +7197,7 @@
           <a:lstStyle/>
           <a:p>
             <a:pPr>
-              <a:defRPr sz="2400" b="1">
+              <a:defRPr sz="2300" b="1">
                 <a:solidFill>
                   <a:srgbClr val="0F172A"/>
                 </a:solidFill>
@@ -6595,7 +7205,7 @@
               </a:defRPr>
             </a:pPr>
             <a:r>
-              <a:t>Thực Nghiệm Đối Chứng Đa Mô Hình (Fal.ai FLUX 9B vs Gemini 2.0)</a:t>
+              <a:t>Thách Thức Kỹ Thuật: Trạng Thái Cô Lập (t&lt;=40) vs Cạnh Tranh Đồng Thời</a:t>
             </a:r>
           </a:p>
         </p:txBody>
@@ -6645,40 +7255,16 @@
           </a:p>
         </p:txBody>
       </p:sp>
-      <p:pic>
-        <p:nvPicPr>
-          <p:cNvPr id="7" name="Picture 6" descr="fal_ai_9b_test.png"/>
-          <p:cNvPicPr>
-            <a:picLocks noChangeAspect="1"/>
-          </p:cNvPicPr>
-          <p:nvPr/>
-        </p:nvPicPr>
-        <p:blipFill>
-          <a:blip r:embed="rId2"/>
-          <a:stretch>
-            <a:fillRect/>
-          </a:stretch>
-        </p:blipFill>
-        <p:spPr>
-          <a:xfrm>
-            <a:off x="914400" y="1828800"/>
-            <a:ext cx="4892040" cy="2743200"/>
-          </a:xfrm>
-          <a:prstGeom prst="rect">
-            <a:avLst/>
-          </a:prstGeom>
-        </p:spPr>
-      </p:pic>
-      <p:sp>
-        <p:nvSpPr>
-          <p:cNvPr id="8" name="TextBox 7"/>
+      <p:sp>
+        <p:nvSpPr>
+          <p:cNvPr id="7" name="TextBox 6"/>
           <p:cNvSpPr txBox="1"/>
           <p:nvPr/>
         </p:nvSpPr>
         <p:spPr>
           <a:xfrm>
-            <a:off x="914400" y="4663440"/>
-            <a:ext cx="4892040" cy="1188720"/>
+            <a:off x="960120" y="1874520"/>
+            <a:ext cx="4800600" cy="3931920"/>
           </a:xfrm>
           <a:prstGeom prst="rect">
             <a:avLst/>
@@ -6692,21 +7278,49 @@
           <a:lstStyle/>
           <a:p>
             <a:pPr>
-              <a:defRPr sz="1100">
-                <a:solidFill>
-                  <a:srgbClr val="D97706"/>
-                </a:solidFill>
-              </a:defRPr>
-            </a:pPr>
-            <a:r>
-              <a:t>⚠️ FLUX.2 KLEIN 9B (ZERO-SHOT): Giữ được t=10 &amp; t=20, nhưng sụp đổ ở t=30 thành chữ rác 'ÔUÔ-DAT!' do bão hòa Attention.</a:t>
-            </a:r>
-          </a:p>
-        </p:txBody>
-      </p:sp>
-      <p:sp>
-        <p:nvSpPr>
-          <p:cNvPr id="9" name="Rounded Rectangle 8"/>
+              <a:defRPr sz="1400" b="1">
+                <a:solidFill>
+                  <a:srgbClr val="059669"/>
+                </a:solidFill>
+              </a:defRPr>
+            </a:pPr>
+            <a:r>
+              <a:t>🟢 TRẠNG THÁI CÔ LẬP (PROBE SUITE 1)</a:t>
+            </a:r>
+          </a:p>
+          <a:p>
+            <a:pPr>
+              <a:spcBef>
+                <a:spcPts val="1000"/>
+              </a:spcBef>
+              <a:defRPr sz="1200">
+                <a:solidFill>
+                  <a:srgbClr val="0F172A"/>
+                </a:solidFill>
+              </a:defRPr>
+            </a:pPr>
+            <a:r>
+              <a:t>• Khi chạy từng kênh đơn lẻ:</a:t>
+            </a:r>
+            <a:br/>
+            <a:r>
+              <a:t>  Kênh t=10.0, 20.0, 30.0, 40.0 ĐỀU VẼ CHỮ 3D ĐẸP 100% CHUẨN XÁC.</a:t>
+            </a:r>
+            <a:br/>
+            <a:r>
+              <a:t>• Chỉ bắt đầu suy hao góc quay RoPE tại t &gt;= 50.0.</a:t>
+            </a:r>
+            <a:br/>
+            <a:br/>
+            <a:r>
+              <a:t>👉 Ý nghĩa: Mô hình Base ĐÃ CÓ SẴN năng lực biểu diễn chữ ở dải t &lt;= 40.0!</a:t>
+            </a:r>
+          </a:p>
+        </p:txBody>
+      </p:sp>
+      <p:sp>
+        <p:nvSpPr>
+          <p:cNvPr id="8" name="Rounded Rectangle 7"/>
           <p:cNvSpPr/>
           <p:nvPr/>
         </p:nvSpPr>
@@ -6749,40 +7363,16 @@
           </a:p>
         </p:txBody>
       </p:sp>
-      <p:pic>
-        <p:nvPicPr>
-          <p:cNvPr id="10" name="Picture 9" descr="gemini_teacher_test.jpg"/>
-          <p:cNvPicPr>
-            <a:picLocks noChangeAspect="1"/>
-          </p:cNvPicPr>
-          <p:nvPr/>
-        </p:nvPicPr>
-        <p:blipFill>
-          <a:blip r:embed="rId3"/>
-          <a:stretch>
-            <a:fillRect/>
-          </a:stretch>
-        </p:blipFill>
-        <p:spPr>
-          <a:xfrm>
-            <a:off x="6355080" y="1828800"/>
-            <a:ext cx="4892040" cy="2743200"/>
-          </a:xfrm>
-          <a:prstGeom prst="rect">
-            <a:avLst/>
-          </a:prstGeom>
-        </p:spPr>
-      </p:pic>
-      <p:sp>
-        <p:nvSpPr>
-          <p:cNvPr id="11" name="TextBox 10"/>
+      <p:sp>
+        <p:nvSpPr>
+          <p:cNvPr id="9" name="TextBox 8"/>
           <p:cNvSpPr txBox="1"/>
           <p:nvPr/>
         </p:nvSpPr>
         <p:spPr>
           <a:xfrm>
-            <a:off x="6355080" y="4663440"/>
-            <a:ext cx="4892040" cy="1188720"/>
+            <a:off x="6400800" y="1874520"/>
+            <a:ext cx="4800600" cy="3931920"/>
           </a:xfrm>
           <a:prstGeom prst="rect">
             <a:avLst/>
@@ -6796,14 +7386,43 @@
           <a:lstStyle/>
           <a:p>
             <a:pPr>
-              <a:defRPr sz="1100">
-                <a:solidFill>
-                  <a:srgbClr val="059669"/>
-                </a:solidFill>
-              </a:defRPr>
-            </a:pPr>
-            <a:r>
-              <a:t>✅ GEMINI 2.0 (DISTILLATION TEACHER): CHUẨN XÁC 100% CẢ 3 KHỐI TEXT (Đủ 4 dấu kép khó nhất) + Giữ trọn tai nghe + Bố cục thương mại đỉnh cao!</a:t>
+              <a:defRPr sz="1400" b="1">
+                <a:solidFill>
+                  <a:srgbClr val="D97706"/>
+                </a:solidFill>
+              </a:defRPr>
+            </a:pPr>
+            <a:r>
+              <a:t>🔴 TRẠNG THÁI CẠNH TRANH (PROBE SUITE 2)</a:t>
+            </a:r>
+          </a:p>
+          <a:p>
+            <a:pPr>
+              <a:spcBef>
+                <a:spcPts val="1000"/>
+              </a:spcBef>
+              <a:defRPr sz="1200">
+                <a:solidFill>
+                  <a:srgbClr val="0F172A"/>
+                </a:solidFill>
+              </a:defRPr>
+            </a:pPr>
+            <a:r>
+              <a:t>• Khi đưa đồng thời 3-4 Slot:</a:t>
+            </a:r>
+            <a:br/>
+            <a:r>
+              <a:t>  Attention Heads bị hiện tượng Tranh chấp &amp; Tràn kênh (Cross-Slot Bleeding) -&gt; Slot giữa bị đè mất.</a:t>
+            </a:r>
+            <a:br/>
+            <a:br/>
+            <a:r>
+              <a:t>• Ảnh sản phẩm (4096 tokens) luôn thắng thế nhờ Token Mass Dominance.</a:t>
+            </a:r>
+            <a:br/>
+            <a:br/>
+            <a:r>
+              <a:t>👉 Mục tiêu LoRA Phase 3: Dạy DiT phân luồng Attention độc lập giữa các slot!</a:t>
             </a:r>
           </a:p>
         </p:txBody>
@@ -6900,7 +7519,7 @@
               </a:defRPr>
             </a:pPr>
             <a:r>
-              <a:t>TENDOO AI  |  CHIẾN LƯỢC CHUYỂN GIAO TRI THỨC</a:t>
+              <a:t>TENDOO AI  |  BẰNG CHỨNG THỰC NGHIỆM TRỰC QUAN</a:t>
             </a:r>
           </a:p>
         </p:txBody>
@@ -6936,7 +7555,7 @@
               </a:defRPr>
             </a:pPr>
             <a:r>
-              <a:t>09 / 10</a:t>
+              <a:t>09 / 11</a:t>
             </a:r>
           </a:p>
         </p:txBody>
@@ -6964,7 +7583,7 @@
           <a:lstStyle/>
           <a:p>
             <a:pPr>
-              <a:defRPr sz="2400" b="1">
+              <a:defRPr sz="2300" b="1">
                 <a:solidFill>
                   <a:srgbClr val="0F172A"/>
                 </a:solidFill>
@@ -6972,7 +7591,7 @@
               </a:defRPr>
             </a:pPr>
             <a:r>
-              <a:t>Chiến Lược Huấn Luyện LoRA DiT 4B Base (Phase 3 Master Roadmap)</a:t>
+              <a:t>Thực Nghiệm Đối Chứng Đa Mô Hình (Fal.ai FLUX 9B vs Gemini 2.0)</a:t>
             </a:r>
           </a:p>
         </p:txBody>
@@ -6986,7 +7605,7 @@
         <p:spPr>
           <a:xfrm>
             <a:off x="731520" y="1645920"/>
-            <a:ext cx="3456432" cy="4389120"/>
+            <a:ext cx="5257800" cy="4389120"/>
           </a:xfrm>
           <a:prstGeom prst="roundRect">
             <a:avLst/>
@@ -7022,16 +7641,40 @@
           </a:p>
         </p:txBody>
       </p:sp>
-      <p:sp>
-        <p:nvSpPr>
-          <p:cNvPr id="7" name="TextBox 6"/>
+      <p:pic>
+        <p:nvPicPr>
+          <p:cNvPr id="7" name="Picture 6" descr="fal_ai_9b_test.png"/>
+          <p:cNvPicPr>
+            <a:picLocks noChangeAspect="1"/>
+          </p:cNvPicPr>
+          <p:nvPr/>
+        </p:nvPicPr>
+        <p:blipFill>
+          <a:blip r:embed="rId2"/>
+          <a:stretch>
+            <a:fillRect/>
+          </a:stretch>
+        </p:blipFill>
+        <p:spPr>
+          <a:xfrm>
+            <a:off x="914400" y="1828800"/>
+            <a:ext cx="4892040" cy="2743200"/>
+          </a:xfrm>
+          <a:prstGeom prst="rect">
+            <a:avLst/>
+          </a:prstGeom>
+        </p:spPr>
+      </p:pic>
+      <p:sp>
+        <p:nvSpPr>
+          <p:cNvPr id="8" name="TextBox 7"/>
           <p:cNvSpPr txBox="1"/>
           <p:nvPr/>
         </p:nvSpPr>
         <p:spPr>
           <a:xfrm>
-            <a:off x="914400" y="1828800"/>
-            <a:ext cx="3090672" cy="4023360"/>
+            <a:off x="914400" y="4663440"/>
+            <a:ext cx="4892040" cy="1188720"/>
           </a:xfrm>
           <a:prstGeom prst="rect">
             <a:avLst/>
@@ -7045,162 +7688,28 @@
           <a:lstStyle/>
           <a:p>
             <a:pPr>
-              <a:defRPr sz="1400" b="1">
-                <a:solidFill>
-                  <a:srgbClr val="0F172A"/>
-                </a:solidFill>
-              </a:defRPr>
-            </a:pPr>
-            <a:r>
-              <a:t>MILESTONE A (600 steps)</a:t>
-            </a:r>
-          </a:p>
-          <a:p>
-            <a:pPr>
-              <a:spcBef>
-                <a:spcPts val="1400"/>
-              </a:spcBef>
-              <a:defRPr sz="1200">
-                <a:solidFill>
-                  <a:srgbClr val="0F172A"/>
-                </a:solidFill>
-              </a:defRPr>
-            </a:pPr>
-            <a:r>
-              <a:t>Hòa Trộn 1 SP + 1 Headline</a:t>
-            </a:r>
-            <a:br/>
-            <a:r>
-              <a:t>• 500 mẫu (300 SP + 200 T2I)</a:t>
-            </a:r>
-            <a:br/>
-            <a:r>
-              <a:t>• Cân bằng Softmax giữa mỏ neo 4096 tokens và Headline.</a:t>
-            </a:r>
-            <a:br/>
-            <a:r>
-              <a:t>• Nghiệm thu: Headline 100%, SP &gt;= 98%.</a:t>
-            </a:r>
-          </a:p>
-        </p:txBody>
-      </p:sp>
-      <p:sp>
-        <p:nvSpPr>
-          <p:cNvPr id="8" name="Rounded Rectangle 7"/>
+              <a:defRPr sz="1100">
+                <a:solidFill>
+                  <a:srgbClr val="D97706"/>
+                </a:solidFill>
+              </a:defRPr>
+            </a:pPr>
+            <a:r>
+              <a:t>⚠️ FLUX.2 KLEIN 9B (ZERO-SHOT): Giữ được t=10 &amp; t=20, nhưng sụp đổ ở t=30 thành chữ rác 'ÔUÔ-DAT!' do bão hòa Attention.</a:t>
+            </a:r>
+          </a:p>
+        </p:txBody>
+      </p:sp>
+      <p:sp>
+        <p:nvSpPr>
+          <p:cNvPr id="9" name="Rounded Rectangle 8"/>
           <p:cNvSpPr/>
           <p:nvPr/>
         </p:nvSpPr>
         <p:spPr>
           <a:xfrm>
-            <a:off x="4370832" y="1645920"/>
-            <a:ext cx="3456432" cy="4389120"/>
-          </a:xfrm>
-          <a:prstGeom prst="roundRect">
-            <a:avLst/>
-          </a:prstGeom>
-          <a:solidFill>
-            <a:srgbClr val="FFFFFF"/>
-          </a:solidFill>
-          <a:ln w="15240">
-            <a:solidFill>
-              <a:srgbClr val="E2E8F0"/>
-            </a:solidFill>
-          </a:ln>
-        </p:spPr>
-        <p:style>
-          <a:lnRef idx="1">
-            <a:schemeClr val="accent1"/>
-          </a:lnRef>
-          <a:fillRef idx="3">
-            <a:schemeClr val="accent1"/>
-          </a:fillRef>
-          <a:effectRef idx="2">
-            <a:schemeClr val="accent1"/>
-          </a:effectRef>
-          <a:fontRef idx="minor">
-            <a:schemeClr val="lt1"/>
-          </a:fontRef>
-        </p:style>
-        <p:txBody>
-          <a:bodyPr rtlCol="0" anchor="ctr"/>
-          <a:lstStyle/>
-          <a:p>
-            <a:pPr algn="ctr"/>
-          </a:p>
-        </p:txBody>
-      </p:sp>
-      <p:sp>
-        <p:nvSpPr>
-          <p:cNvPr id="9" name="TextBox 8"/>
-          <p:cNvSpPr txBox="1"/>
-          <p:nvPr/>
-        </p:nvSpPr>
-        <p:spPr>
-          <a:xfrm>
-            <a:off x="4553712" y="1828800"/>
-            <a:ext cx="3090672" cy="4023360"/>
-          </a:xfrm>
-          <a:prstGeom prst="rect">
-            <a:avLst/>
-          </a:prstGeom>
-          <a:noFill/>
-        </p:spPr>
-        <p:txBody>
-          <a:bodyPr wrap="square">
-            <a:spAutoFit/>
-          </a:bodyPr>
-          <a:lstStyle/>
-          <a:p>
-            <a:pPr>
-              <a:defRPr sz="1400" b="1">
-                <a:solidFill>
-                  <a:srgbClr val="0F172A"/>
-                </a:solidFill>
-              </a:defRPr>
-            </a:pPr>
-            <a:r>
-              <a:t>MILESTONE B (1,200 steps)</a:t>
-            </a:r>
-          </a:p>
-          <a:p>
-            <a:pPr>
-              <a:spcBef>
-                <a:spcPts val="1400"/>
-              </a:spcBef>
-              <a:defRPr sz="1200">
-                <a:solidFill>
-                  <a:srgbClr val="0F172A"/>
-                </a:solidFill>
-              </a:defRPr>
-            </a:pPr>
-            <a:r>
-              <a:t>Tách Kênh 2 Khối Text</a:t>
-            </a:r>
-            <a:br/>
-            <a:r>
-              <a:t>• 1,500 mẫu (900 SP + 600 T2I)</a:t>
-            </a:r>
-            <a:br/>
-            <a:r>
-              <a:t>• Kích hoạt phân luồng kênh t=20, triệt tiêu rò rỉ Ref-to-Ref.</a:t>
-            </a:r>
-            <a:br/>
-            <a:r>
-              <a:t>• Nghiệm thu: Cả 2 dòng chữ render đúng 100%.</a:t>
-            </a:r>
-          </a:p>
-        </p:txBody>
-      </p:sp>
-      <p:sp>
-        <p:nvSpPr>
-          <p:cNvPr id="10" name="Rounded Rectangle 9"/>
-          <p:cNvSpPr/>
-          <p:nvPr/>
-        </p:nvSpPr>
-        <p:spPr>
-          <a:xfrm>
-            <a:off x="8010144" y="1645920"/>
-            <a:ext cx="3456432" cy="4389120"/>
+            <a:off x="6172200" y="1645920"/>
+            <a:ext cx="5257800" cy="4389120"/>
           </a:xfrm>
           <a:prstGeom prst="roundRect">
             <a:avLst/>
@@ -7236,6 +7745,30 @@
           </a:p>
         </p:txBody>
       </p:sp>
+      <p:pic>
+        <p:nvPicPr>
+          <p:cNvPr id="10" name="Picture 9" descr="gemini_teacher_test.jpg"/>
+          <p:cNvPicPr>
+            <a:picLocks noChangeAspect="1"/>
+          </p:cNvPicPr>
+          <p:nvPr/>
+        </p:nvPicPr>
+        <p:blipFill>
+          <a:blip r:embed="rId3"/>
+          <a:stretch>
+            <a:fillRect/>
+          </a:stretch>
+        </p:blipFill>
+        <p:spPr>
+          <a:xfrm>
+            <a:off x="6355080" y="1828800"/>
+            <a:ext cx="4892040" cy="2743200"/>
+          </a:xfrm>
+          <a:prstGeom prst="rect">
+            <a:avLst/>
+          </a:prstGeom>
+        </p:spPr>
+      </p:pic>
       <p:sp>
         <p:nvSpPr>
           <p:cNvPr id="11" name="TextBox 10"/>
@@ -7244,8 +7777,8 @@
         </p:nvSpPr>
         <p:spPr>
           <a:xfrm>
-            <a:off x="8193024" y="1828800"/>
-            <a:ext cx="3090672" cy="4023360"/>
+            <a:off x="6355080" y="4663440"/>
+            <a:ext cx="4892040" cy="1188720"/>
           </a:xfrm>
           <a:prstGeom prst="rect">
             <a:avLst/>
@@ -7259,41 +7792,14 @@
           <a:lstStyle/>
           <a:p>
             <a:pPr>
-              <a:defRPr sz="1400" b="1">
-                <a:solidFill>
-                  <a:srgbClr val="0284C7"/>
-                </a:solidFill>
-              </a:defRPr>
-            </a:pPr>
-            <a:r>
-              <a:t>MILESTONE C (2,200 steps)</a:t>
-            </a:r>
-          </a:p>
-          <a:p>
-            <a:pPr>
-              <a:spcBef>
-                <a:spcPts val="1400"/>
-              </a:spcBef>
-              <a:defRPr sz="1200">
-                <a:solidFill>
-                  <a:srgbClr val="0F172A"/>
-                </a:solidFill>
-              </a:defRPr>
-            </a:pPr>
-            <a:r>
-              <a:t>Full 4-5 Slot Production</a:t>
-            </a:r>
-            <a:br/>
-            <a:r>
-              <a:t>• 2,500 mẫu toàn diện</a:t>
-            </a:r>
-            <a:br/>
-            <a:r>
-              <a:t>• Khóa cứng Attention 3-4 khối text (gồm Tier Cực Hạn 5-slot).</a:t>
-            </a:r>
-            <a:br/>
-            <a:r>
-              <a:t>• Nghiệm thu: Benchmark đạt &gt;= 95% tổng thể.</a:t>
+              <a:defRPr sz="1100">
+                <a:solidFill>
+                  <a:srgbClr val="059669"/>
+                </a:solidFill>
+              </a:defRPr>
+            </a:pPr>
+            <a:r>
+              <a:t>✅ GEMINI 2.0 (DISTILLATION TEACHER): CHUẨN XÁC 100% CẢ 3 KHỐI TEXT (Đủ 4 dấu kép khó nhất) + Giữ trọn tai nghe + Bố cục thương mại đỉnh cao!</a:t>
             </a:r>
           </a:p>
         </p:txBody>

</xml_diff>